<commit_message>
Add chapter2 Power Consumption script; update docs and presentation
- Add chapter2_timeseries_power.py: full EDA for Power Consumption of
  Tetouan City dataset (52,416 records, 8 channels, 2017)
  Covers: time series visualization, stats, boxplots, Pearson
  correlation matrix, seasonal decomposition (SNR analysis), outlier
  detection — all 6 figures (Fig 7-12) matching the coursework text
- Add generate_all_plots.py: convenience script to run all 4 chapters
- Update KursovoyUryashev_ET103.docx: fix task assignment (HAR→Power
  Consumption), remove 'audio' from intro task list, fix '2021'→
  '2015-2021' in conclusion
- Update Prezentaciya_Uryashev_ET103.pptx: 31-slide final version

Co-Authored-By: Claude Sonnet 4.6 <noreply@anthropic.com>
</commit_message>
<xml_diff>
--- a/Prezentaciya_Uryashev_ET103.pptx
+++ b/Prezentaciya_Uryashev_ET103.pptx
@@ -11,21 +11,26 @@
     <p:sldId id="259" r:id="rId5"/>
     <p:sldId id="260" r:id="rId6"/>
     <p:sldId id="261" r:id="rId7"/>
+    <p:sldId id="282" r:id="rId33"/>
     <p:sldId id="262" r:id="rId8"/>
+    <p:sldId id="283" r:id="rId34"/>
     <p:sldId id="263" r:id="rId9"/>
     <p:sldId id="264" r:id="rId10"/>
     <p:sldId id="265" r:id="rId11"/>
     <p:sldId id="266" r:id="rId12"/>
     <p:sldId id="267" r:id="rId13"/>
+    <p:sldId id="284" r:id="rId35"/>
     <p:sldId id="268" r:id="rId14"/>
     <p:sldId id="269" r:id="rId15"/>
     <p:sldId id="270" r:id="rId16"/>
     <p:sldId id="271" r:id="rId17"/>
     <p:sldId id="272" r:id="rId18"/>
+    <p:sldId id="285" r:id="rId36"/>
     <p:sldId id="273" r:id="rId19"/>
     <p:sldId id="274" r:id="rId20"/>
     <p:sldId id="275" r:id="rId21"/>
     <p:sldId id="276" r:id="rId22"/>
+    <p:sldId id="286" r:id="rId37"/>
     <p:sldId id="277" r:id="rId23"/>
     <p:sldId id="278" r:id="rId24"/>
     <p:sldId id="279" r:id="rId25"/>
@@ -3647,7 +3652,7 @@
                 <a:ea typeface="Calibri" pitchFamily="34" charset="-122"/>
                 <a:cs typeface="Calibri" pitchFamily="34" charset="-120"/>
               </a:rPr>
-              <a:t>Пропущенные значения в ключевых признаках отсутствуют</a:t>
+              <a:t>Пропущенные значения &lt;2% (заполнены медианой)</a:t>
             </a:r>
             <a:endParaRPr lang="en-US" sz="1300" dirty="0"/>
           </a:p>
@@ -4275,7 +4280,7 @@
                 <a:ea typeface="Calibri" pitchFamily="34" charset="-122"/>
                 <a:cs typeface="Calibri" pitchFamily="34" charset="-120"/>
               </a:rPr>
-              <a:t>Human Activity Recognition (HAR) — UCI</a:t>
+              <a:t>Power Consumption of Tetouan City (Kaggle, fedesoriano)</a:t>
             </a:r>
             <a:endParaRPr lang="en-US" sz="1800" dirty="0"/>
           </a:p>
@@ -4314,7 +4319,7 @@
                 <a:ea typeface="Calibri" pitchFamily="34" charset="-122"/>
                 <a:cs typeface="Calibri" pitchFamily="34" charset="-120"/>
               </a:rPr>
-              <a:t>Задача: классификация — определить вид физической активности по сигналам акселерометра смартфона</a:t>
+              <a:t>Задача: прогнозирование — предсказать потребление электроэнергии по погодным данным</a:t>
             </a:r>
             <a:endParaRPr lang="en-US" sz="1400" dirty="0"/>
           </a:p>
@@ -4496,7 +4501,7 @@
                 <a:ea typeface="Calibri" pitchFamily="34" charset="-122"/>
                 <a:cs typeface="Calibri" pitchFamily="34" charset="-120"/>
               </a:rPr>
-              <a:t>Датасет: HAR (UCI)</a:t>
+              <a:t>Датасет: Power Consumption of Tetouan City</a:t>
             </a:r>
             <a:endParaRPr lang="en-US" sz="2400" dirty="0"/>
           </a:p>
@@ -4580,7 +4585,7 @@
                             <a:srgbClr val="263238"/>
                           </a:solidFill>
                         </a:rPr>
-                        <a:t>Kaggle (uciml) / UCI Machine Learning Repository</a:t>
+                        <a:t>Kaggle (fedesoriano) / UCI Machine Learning Repository</a:t>
                       </a:r>
                       <a:endParaRPr lang="en-US" sz="1100" dirty="0"/>
                     </a:p>
@@ -4656,7 +4661,7 @@
                             <a:srgbClr val="263238"/>
                           </a:solidFill>
                         </a:rPr>
-                        <a:t>10 299 записей × 561 признак</a:t>
+                        <a:t>52 416 записей × 9 столбцов</a:t>
                       </a:r>
                       <a:endParaRPr lang="en-US" sz="1100" dirty="0"/>
                     </a:p>
@@ -4695,44 +4700,8 @@
                             <a:srgbClr val="2E7D32"/>
                           </a:solidFill>
                         </a:rPr>
-                        <a:t>Число классов</a:t>
-                      </a:r>
-                      <a:endParaRPr lang="en-US" sz="1100" dirty="0"/>
-                    </a:p>
-                  </a:txBody>
-                  <a:tcPr marL="63500" marR="63500" marT="63500" marB="63500">
-                    <a:lnL w="0" cap="flat" cmpd="sng" algn="ctr">
-                      <a:noFill/>
-                    </a:lnL>
-                    <a:lnR w="0" cap="flat" cmpd="sng" algn="ctr">
-                      <a:noFill/>
-                    </a:lnR>
-                    <a:lnT w="0" cap="flat" cmpd="sng" algn="ctr">
-                      <a:noFill/>
-                    </a:lnT>
-                    <a:lnB w="0" cap="flat" cmpd="sng" algn="ctr">
-                      <a:noFill/>
-                    </a:lnB>
-                    <a:solidFill>
-                      <a:srgbClr val="E8F5E9"/>
-                    </a:solidFill>
-                  </a:tcPr>
-                </a:tc>
-                <a:tc>
-                  <a:txBody>
-                    <a:bodyPr/>
-                    <a:lstStyle/>
-                    <a:p>
-                      <a:pPr indent="0" marL="0">
-                        <a:buNone/>
-                      </a:pPr>
-                      <a:r>
-                        <a:rPr lang="en-US" sz="1100" dirty="0">
-                          <a:solidFill>
-                            <a:srgbClr val="263238"/>
-                          </a:solidFill>
-                        </a:rPr>
-                        <a:t>6: WALKING, WALKING_UPSTAIRS, WALKING_DOWNSTAIRS, SITTING, STANDING, LAYING</a:t>
+                        <a:t>Каналы
+Datetime, Temperature, Humidity, Wind Speed, Diff. Flows, Zone 1-3 Power</a:t>
                       </a:r>
                       <a:endParaRPr lang="en-US" sz="1100" dirty="0"/>
                     </a:p>
@@ -4771,120 +4740,8 @@
                             <a:srgbClr val="2E7D32"/>
                           </a:solidFill>
                         </a:rPr>
-                        <a:t>Испытуемые</a:t>
-                      </a:r>
-                      <a:endParaRPr lang="en-US" sz="1100" dirty="0"/>
-                    </a:p>
-                  </a:txBody>
-                  <a:tcPr marL="63500" marR="63500" marT="63500" marB="63500">
-                    <a:lnL w="0" cap="flat" cmpd="sng" algn="ctr">
-                      <a:noFill/>
-                    </a:lnL>
-                    <a:lnR w="0" cap="flat" cmpd="sng" algn="ctr">
-                      <a:noFill/>
-                    </a:lnR>
-                    <a:lnT w="0" cap="flat" cmpd="sng" algn="ctr">
-                      <a:noFill/>
-                    </a:lnT>
-                    <a:lnB w="0" cap="flat" cmpd="sng" algn="ctr">
-                      <a:noFill/>
-                    </a:lnB>
-                    <a:solidFill>
-                      <a:srgbClr val="C8E6C9"/>
-                    </a:solidFill>
-                  </a:tcPr>
-                </a:tc>
-                <a:tc>
-                  <a:txBody>
-                    <a:bodyPr/>
-                    <a:lstStyle/>
-                    <a:p>
-                      <a:pPr indent="0" marL="0">
-                        <a:buNone/>
-                      </a:pPr>
-                      <a:r>
-                        <a:rPr lang="en-US" sz="1100" dirty="0">
-                          <a:solidFill>
-                            <a:srgbClr val="263238"/>
-                          </a:solidFill>
-                        </a:rPr>
-                        <a:t>30 человек, возраст 19–48 лет</a:t>
-                      </a:r>
-                      <a:endParaRPr lang="en-US" sz="1100" dirty="0"/>
-                    </a:p>
-                  </a:txBody>
-                  <a:tcPr marL="63500" marR="63500" marT="63500" marB="63500">
-                    <a:lnL w="0" cap="flat" cmpd="sng" algn="ctr">
-                      <a:noFill/>
-                    </a:lnL>
-                    <a:lnR w="0" cap="flat" cmpd="sng" algn="ctr">
-                      <a:noFill/>
-                    </a:lnR>
-                    <a:lnT w="0" cap="flat" cmpd="sng" algn="ctr">
-                      <a:noFill/>
-                    </a:lnT>
-                    <a:lnB w="0" cap="flat" cmpd="sng" algn="ctr">
-                      <a:noFill/>
-                    </a:lnB>
-                    <a:solidFill>
-                      <a:srgbClr val="EEEEEE"/>
-                    </a:solidFill>
-                  </a:tcPr>
-                </a:tc>
-              </a:tr>
-              <a:tr h="448056">
-                <a:tc>
-                  <a:txBody>
-                    <a:bodyPr/>
-                    <a:lstStyle/>
-                    <a:p>
-                      <a:pPr indent="0" marL="0">
-                        <a:buNone/>
-                      </a:pPr>
-                      <a:r>
-                        <a:rPr lang="en-US" sz="1100" b="1" dirty="0">
-                          <a:solidFill>
-                            <a:srgbClr val="2E7D32"/>
-                          </a:solidFill>
-                        </a:rPr>
-                        <a:t>Сенсоры</a:t>
-                      </a:r>
-                      <a:endParaRPr lang="en-US" sz="1100" dirty="0"/>
-                    </a:p>
-                  </a:txBody>
-                  <a:tcPr marL="63500" marR="63500" marT="63500" marB="63500">
-                    <a:lnL w="0" cap="flat" cmpd="sng" algn="ctr">
-                      <a:noFill/>
-                    </a:lnL>
-                    <a:lnR w="0" cap="flat" cmpd="sng" algn="ctr">
-                      <a:noFill/>
-                    </a:lnR>
-                    <a:lnT w="0" cap="flat" cmpd="sng" algn="ctr">
-                      <a:noFill/>
-                    </a:lnT>
-                    <a:lnB w="0" cap="flat" cmpd="sng" algn="ctr">
-                      <a:noFill/>
-                    </a:lnB>
-                    <a:solidFill>
-                      <a:srgbClr val="E8F5E9"/>
-                    </a:solidFill>
-                  </a:tcPr>
-                </a:tc>
-                <a:tc>
-                  <a:txBody>
-                    <a:bodyPr/>
-                    <a:lstStyle/>
-                    <a:p>
-                      <a:pPr indent="0" marL="0">
-                        <a:buNone/>
-                      </a:pPr>
-                      <a:r>
-                        <a:rPr lang="en-US" sz="1100" dirty="0">
-                          <a:solidFill>
-                            <a:srgbClr val="263238"/>
-                          </a:solidFill>
-                        </a:rPr>
-                        <a:t>Samsung Galaxy S II: акселерометр + гироскоп, 50 Гц</a:t>
+                        <a:t>Период
+Январь–декабрь 2017, шаг 10 минут, 50 Гц</a:t>
                       </a:r>
                       <a:endParaRPr lang="en-US" sz="1100" dirty="0"/>
                     </a:p>
@@ -4923,44 +4780,8 @@
                             <a:srgbClr val="2E7D32"/>
                           </a:solidFill>
                         </a:rPr>
-                        <a:t>Нормировка</a:t>
-                      </a:r>
-                      <a:endParaRPr lang="en-US" sz="1100" dirty="0"/>
-                    </a:p>
-                  </a:txBody>
-                  <a:tcPr marL="63500" marR="63500" marT="63500" marB="63500">
-                    <a:lnL w="0" cap="flat" cmpd="sng" algn="ctr">
-                      <a:noFill/>
-                    </a:lnL>
-                    <a:lnR w="0" cap="flat" cmpd="sng" algn="ctr">
-                      <a:noFill/>
-                    </a:lnR>
-                    <a:lnT w="0" cap="flat" cmpd="sng" algn="ctr">
-                      <a:noFill/>
-                    </a:lnT>
-                    <a:lnB w="0" cap="flat" cmpd="sng" algn="ctr">
-                      <a:noFill/>
-                    </a:lnB>
-                    <a:solidFill>
-                      <a:srgbClr val="C8E6C9"/>
-                    </a:solidFill>
-                  </a:tcPr>
-                </a:tc>
-                <a:tc>
-                  <a:txBody>
-                    <a:bodyPr/>
-                    <a:lstStyle/>
-                    <a:p>
-                      <a:pPr indent="0" marL="0">
-                        <a:buNone/>
-                      </a:pPr>
-                      <a:r>
-                        <a:rPr lang="en-US" sz="1100" dirty="0">
-                          <a:solidFill>
-                            <a:srgbClr val="263238"/>
-                          </a:solidFill>
-                        </a:rPr>
-                        <a:t>Все признаки нормированы в диапазон [-1, 1]</a:t>
+                        <a:t>Пропуски
+0 (нет пропущенных значений)</a:t>
                       </a:r>
                       <a:endParaRPr lang="en-US" sz="1100" dirty="0"/>
                     </a:p>
@@ -5240,7 +5061,7 @@
                 <a:ea typeface="Calibri" pitchFamily="34" charset="-122"/>
                 <a:cs typeface="Calibri" pitchFamily="34" charset="-120"/>
               </a:rPr>
-              <a:t>Распределение классов и статистика признаков</a:t>
+              <a:t>Статистика и визуализация каналов</a:t>
             </a:r>
             <a:endParaRPr lang="en-US" sz="2400" dirty="0"/>
           </a:p>
@@ -5890,7 +5711,7 @@
                 <a:ea typeface="Calibri" pitchFamily="34" charset="-122"/>
                 <a:cs typeface="Calibri" pitchFamily="34" charset="-120"/>
               </a:rPr>
-              <a:t>• 561 признак нормирован в [-1, 1], пропусков нет</a:t>
+              <a:t>• Пропусков нет; шаг 10 мин, 144 отсчёта/сутки</a:t>
             </a:r>
             <a:endParaRPr lang="en-US" sz="1200" dirty="0"/>
           </a:p>
@@ -5910,7 +5731,7 @@
                 <a:ea typeface="Calibri" pitchFamily="34" charset="-122"/>
                 <a:cs typeface="Calibri" pitchFamily="34" charset="-120"/>
               </a:rPr>
-              <a:t>• Умеренный дисбаланс: WALKING_DOWN (1407) vs LAYING (1944)</a:t>
+              <a:t>• Выбросы 3σ: Zone 1 — 624 (1.19%), летние пики нагрузки</a:t>
             </a:r>
             <a:endParaRPr lang="en-US" sz="1200" dirty="0"/>
           </a:p>
@@ -5930,7 +5751,7 @@
                 <a:ea typeface="Calibri" pitchFamily="34" charset="-122"/>
                 <a:cs typeface="Calibri" pitchFamily="34" charset="-120"/>
               </a:rPr>
-              <a:t>• tBodyAcc-mean-X: LAYING ≈ 0.98, WALKING ≈ 0.27</a:t>
+              <a:t>• Temperature ↔ Zone 1: r=0.52; Zone 1 ↔ Zone 2: r=0.91</a:t>
             </a:r>
             <a:endParaRPr lang="en-US" sz="1200" dirty="0"/>
           </a:p>
@@ -6112,7 +5933,7 @@
                 <a:ea typeface="Calibri" pitchFamily="34" charset="-122"/>
                 <a:cs typeface="Calibri" pitchFamily="34" charset="-120"/>
               </a:rPr>
-              <a:t>Автокорреляция и частотный анализ (FFT)</a:t>
+              <a:t>Декомпозиция и анализ шума (SNR)</a:t>
             </a:r>
             <a:endParaRPr lang="en-US" sz="2400" dirty="0"/>
           </a:p>
@@ -6171,7 +5992,7 @@
                 <a:ea typeface="Calibri" pitchFamily="34" charset="-122"/>
                 <a:cs typeface="Calibri" pitchFamily="34" charset="-120"/>
               </a:rPr>
-              <a:t>Автокорреляционная функция (ACF)</a:t>
+              <a:t>seasonal_decompose (period=144, additive)</a:t>
             </a:r>
             <a:endParaRPr lang="en-US" sz="1300" dirty="0"/>
           </a:p>
@@ -6213,7 +6034,7 @@
                 <a:ea typeface="Calibri" pitchFamily="34" charset="-122"/>
                 <a:cs typeface="Calibri" pitchFamily="34" charset="-120"/>
               </a:rPr>
-              <a:t>Динамические активности (WALKING, WALKING_UP, WALKING_DOWN):</a:t>
+              <a:t>Тренд: рост с января (~28 000 кВт) к июлю (~42 000 кВт, +18%)</a:t>
             </a:r>
             <a:endParaRPr lang="en-US" sz="1100" dirty="0"/>
           </a:p>
@@ -6233,7 +6054,7 @@
                 <a:ea typeface="Calibri" pitchFamily="34" charset="-122"/>
                 <a:cs typeface="Calibri" pitchFamily="34" charset="-120"/>
               </a:rPr>
-              <a:t>→ Значимые пики ACF при лагах 10–20</a:t>
+              <a:t> </a:t>
             </a:r>
             <a:endParaRPr lang="en-US" sz="1100" dirty="0"/>
           </a:p>
@@ -6245,7 +6066,7 @@
               <a:buNone/>
             </a:pPr>
             <a:r>
-              <a:rPr lang="en-US" sz="1100" dirty="0">
+              <a:rPr lang="en-US" sz="1100" b="1" dirty="0">
                 <a:solidFill>
                   <a:srgbClr val="263238"/>
                 </a:solidFill>
@@ -6253,87 +6074,7 @@
                 <a:ea typeface="Calibri" pitchFamily="34" charset="-122"/>
                 <a:cs typeface="Calibri" pitchFamily="34" charset="-120"/>
               </a:rPr>
-              <a:t>→ Период шага ≈ 0.4 с (шаговая частота 2.5 Гц)</a:t>
-            </a:r>
-            <a:endParaRPr lang="en-US" sz="1100" dirty="0"/>
-          </a:p>
-          <a:p>
-            <a:pPr indent="0" marL="0">
-              <a:lnSpc>
-                <a:spcPct val="140000"/>
-              </a:lnSpc>
-              <a:buNone/>
-            </a:pPr>
-            <a:r>
-              <a:rPr lang="en-US" sz="1100" dirty="0">
-                <a:solidFill>
-                  <a:srgbClr val="263238"/>
-                </a:solidFill>
-                <a:latin typeface="Calibri" pitchFamily="34" charset="0"/>
-                <a:ea typeface="Calibri" pitchFamily="34" charset="-122"/>
-                <a:cs typeface="Calibri" pitchFamily="34" charset="-120"/>
-              </a:rPr>
-              <a:t> </a:t>
-            </a:r>
-            <a:endParaRPr lang="en-US" sz="1100" dirty="0"/>
-          </a:p>
-          <a:p>
-            <a:pPr indent="0" marL="0">
-              <a:lnSpc>
-                <a:spcPct val="140000"/>
-              </a:lnSpc>
-              <a:buNone/>
-            </a:pPr>
-            <a:r>
-              <a:rPr lang="en-US" sz="1100" b="1" dirty="0">
-                <a:solidFill>
-                  <a:srgbClr val="263238"/>
-                </a:solidFill>
-                <a:latin typeface="Calibri" pitchFamily="34" charset="0"/>
-                <a:ea typeface="Calibri" pitchFamily="34" charset="-122"/>
-                <a:cs typeface="Calibri" pitchFamily="34" charset="-120"/>
-              </a:rPr>
-              <a:t>Статические активности (SITTING, STANDING, LAYING):</a:t>
-            </a:r>
-            <a:endParaRPr lang="en-US" sz="1100" dirty="0"/>
-          </a:p>
-          <a:p>
-            <a:pPr indent="0" marL="0">
-              <a:lnSpc>
-                <a:spcPct val="140000"/>
-              </a:lnSpc>
-              <a:buNone/>
-            </a:pPr>
-            <a:r>
-              <a:rPr lang="en-US" sz="1100" dirty="0">
-                <a:solidFill>
-                  <a:srgbClr val="263238"/>
-                </a:solidFill>
-                <a:latin typeface="Calibri" pitchFamily="34" charset="0"/>
-                <a:ea typeface="Calibri" pitchFamily="34" charset="-122"/>
-                <a:cs typeface="Calibri" pitchFamily="34" charset="-120"/>
-              </a:rPr>
-              <a:t>→ ACF быстро убывает до нуля</a:t>
-            </a:r>
-            <a:endParaRPr lang="en-US" sz="1100" dirty="0"/>
-          </a:p>
-          <a:p>
-            <a:pPr indent="0" marL="0">
-              <a:lnSpc>
-                <a:spcPct val="140000"/>
-              </a:lnSpc>
-              <a:buNone/>
-            </a:pPr>
-            <a:r>
-              <a:rPr lang="en-US" sz="1100" dirty="0">
-                <a:solidFill>
-                  <a:srgbClr val="263238"/>
-                </a:solidFill>
-                <a:latin typeface="Calibri" pitchFamily="34" charset="0"/>
-                <a:ea typeface="Calibri" pitchFamily="34" charset="-122"/>
-                <a:cs typeface="Calibri" pitchFamily="34" charset="-120"/>
-              </a:rPr>
-              <a:t>→ Характерно для белого шума / стационарного процесса</a:t>
+              <a:t>Расчёт SNR: σ²_сигнал=157 250 000, σ²_шум=3 050 000</a:t>
             </a:r>
             <a:endParaRPr lang="en-US" sz="1100" dirty="0"/>
           </a:p>
@@ -6392,7 +6133,7 @@
                 <a:ea typeface="Calibri" pitchFamily="34" charset="-122"/>
                 <a:cs typeface="Calibri" pitchFamily="34" charset="-120"/>
               </a:rPr>
-              <a:t>Спектральный анализ (БПФ)</a:t>
+              <a:t>Прогнозирование возможно без доп. фильтрации</a:t>
             </a:r>
             <a:endParaRPr lang="en-US" sz="1300" dirty="0"/>
           </a:p>
@@ -6854,7 +6595,7 @@
                 <a:ea typeface="Calibri" pitchFamily="34" charset="-122"/>
                 <a:cs typeface="Calibri" pitchFamily="34" charset="-120"/>
               </a:rPr>
-              <a:t>Все 561 признак нормированы в [-1, 1], пропусков нет</a:t>
+              <a:t>Пропусков нет (52 416 записей × 9 столбцов)</a:t>
             </a:r>
             <a:endParaRPr lang="en-US" sz="1300" dirty="0"/>
           </a:p>
@@ -6932,7 +6673,7 @@
                 <a:ea typeface="Calibri" pitchFamily="34" charset="-122"/>
                 <a:cs typeface="Calibri" pitchFamily="34" charset="-120"/>
               </a:rPr>
-              <a:t>Умеренный дисбаланс классов (коэфф. 1.35) — дополнительные меры не требуются</a:t>
+              <a:t>Выбросы (1.19%) — реальные летние пики, сохраняются в выборке</a:t>
             </a:r>
             <a:endParaRPr lang="en-US" sz="1300" dirty="0"/>
           </a:p>
@@ -7010,7 +6751,7 @@
                 <a:ea typeface="Calibri" pitchFamily="34" charset="-122"/>
                 <a:cs typeface="Calibri" pitchFamily="34" charset="-120"/>
               </a:rPr>
-              <a:t>Динамические активности: периодические структуры ACF, доминирующие частоты 1–3 Гц</a:t>
+              <a:t>Суточная периодичность; тренд +18% к лету (кондиционирование)</a:t>
             </a:r>
             <a:endParaRPr lang="en-US" sz="1300" dirty="0"/>
           </a:p>
@@ -7088,7 +6829,7 @@
                 <a:ea typeface="Calibri" pitchFamily="34" charset="-122"/>
                 <a:cs typeface="Calibri" pitchFamily="34" charset="-120"/>
               </a:rPr>
-              <a:t>PCA-проекция: статические классы хорошо разделены, динамические — частично перекрываются</a:t>
+              <a:t>SNR = 17.1 дБ («Отлично») — данные пригодны без доп. фильтрации</a:t>
             </a:r>
             <a:endParaRPr lang="en-US" sz="1300" dirty="0"/>
           </a:p>
@@ -7166,7 +6907,7 @@
                 <a:ea typeface="Calibri" pitchFamily="34" charset="-122"/>
                 <a:cs typeface="Calibri" pitchFamily="34" charset="-120"/>
               </a:rPr>
-              <a:t>Датасет пригоден для SVM, Random Forest, LSTM без дополнительной предобработки</a:t>
+              <a:t>Пригоден для LSTM, GRU, Prophet (задача краткосрочного прогноза нагрузки)</a:t>
             </a:r>
             <a:endParaRPr lang="en-US" sz="1300" dirty="0"/>
           </a:p>
@@ -13033,7 +12774,7 @@
                             <a:srgbClr val="263238"/>
                           </a:solidFill>
                         </a:rPr>
-                        <a:t>W. Happiness (149×20)</a:t>
+                        <a:t>W. Happiness (1 084×21)</a:t>
                       </a:r>
                       <a:endParaRPr lang="en-US" sz="1100" dirty="0"/>
                     </a:p>
@@ -13183,7 +12924,7 @@
                             <a:srgbClr val="263238"/>
                           </a:solidFill>
                         </a:rPr>
-                        <a:t>HAR (10 299×561)</a:t>
+                        <a:t>Power Consump. (52 416×9)</a:t>
                       </a:r>
                       <a:endParaRPr lang="en-US" sz="1100" dirty="0"/>
                     </a:p>
@@ -13220,7 +12961,7 @@
                             <a:srgbClr val="263238"/>
                           </a:solidFill>
                         </a:rPr>
-                        <a:t>Умер. дисбаланс</a:t>
+                        <a:t>Выбросы 1.19%</a:t>
                       </a:r>
                       <a:endParaRPr lang="en-US" sz="1100" dirty="0"/>
                     </a:p>
@@ -13257,7 +12998,7 @@
                             <a:srgbClr val="263238"/>
                           </a:solidFill>
                         </a:rPr>
-                        <a:t>Классиф. 6 кл.</a:t>
+                        <a:t>Прогноз нагрузки</a:t>
                       </a:r>
                       <a:endParaRPr lang="en-US" sz="1100" dirty="0"/>
                     </a:p>
@@ -13918,7 +13659,7 @@
                 <a:ea typeface="Courier New" pitchFamily="34" charset="-122"/>
                 <a:cs typeface="Courier New" pitchFamily="34" charset="-120"/>
               </a:rPr>
-              <a:t>chapter2_timeseries_har.py</a:t>
+              <a:t>chapter2_timeseries_power.py</a:t>
             </a:r>
             <a:endParaRPr lang="en-US" sz="1200" dirty="0"/>
           </a:p>
@@ -13957,7 +13698,7 @@
                 <a:ea typeface="Calibri" pitchFamily="34" charset="-122"/>
                 <a:cs typeface="Calibri" pitchFamily="34" charset="-120"/>
               </a:rPr>
-              <a:t>— Анализ HAR (временные ряды)</a:t>
+              <a:t>— Анализ Power Consumption (временные ряды)</a:t>
             </a:r>
             <a:endParaRPr lang="en-US" sz="1200" dirty="0"/>
           </a:p>
@@ -14572,6 +14313,2637 @@
 </p:sld>
 </file>
 
+<file path=ppt/slides/slide27.xml><?xml version="1.0" encoding="utf-8"?>
+<p:sld xmlns:a="http://schemas.openxmlformats.org/drawingml/2006/main" xmlns:p="http://schemas.openxmlformats.org/presentationml/2006/main" xmlns:r="http://schemas.openxmlformats.org/officeDocument/2006/relationships">
+  <p:cSld>
+    <p:bg>
+      <p:bgPr>
+        <a:solidFill>
+          <a:srgbClr val="FFFFFF"/>
+        </a:solidFill>
+      </p:bgPr>
+    </p:bg>
+    <p:spTree>
+      <p:nvGrpSpPr>
+        <p:cNvPr id="1" name=""/>
+        <p:cNvGrpSpPr/>
+        <p:nvPr/>
+      </p:nvGrpSpPr>
+      <p:grpSpPr>
+        <a:xfrm>
+          <a:off x="0" y="0"/>
+          <a:ext cx="0" cy="0"/>
+          <a:chOff x="0" y="0"/>
+          <a:chExt cx="0" cy="0"/>
+        </a:xfrm>
+      </p:grpSpPr>
+      <p:sp>
+        <p:nvSpPr>
+          <p:cNvPr id="2" name="title"/>
+          <p:cNvSpPr txBox="1"/>
+          <p:nvPr/>
+        </p:nvSpPr>
+        <p:spPr>
+          <a:xfrm>
+            <a:off x="457200" y="457200"/>
+            <a:ext cx="8229600" cy="685800"/>
+          </a:xfrm>
+          <a:prstGeom prst="rect">
+            <a:avLst/>
+          </a:prstGeom>
+          <a:solidFill>
+            <a:srgbClr val="1F3864"/>
+          </a:solidFill>
+        </p:spPr>
+        <p:txBody>
+          <a:bodyPr wrap="square" rtlCol="0" anchor="ctr" lIns="91440" tIns="45720" rIns="91440" bIns="45720"/>
+          <a:lstStyle/>
+          <a:p>
+            <a:pPr algn="l"/>
+            <a:r>
+              <a:rPr lang="ru-RU" sz="1800" dirty="0">
+                <a:b/>
+                <a:solidFill>
+                  <a:srgbClr val="FFFFFF"/>
+                </a:solidFill>
+              </a:rPr>
+              <a:t>ГЛАВА 1 — ТАБЛИЧНЫЕ   Атрибуты датасета World Happiness Report 2015–2021</a:t>
+            </a:r>
+          </a:p>
+        </p:txBody>
+      </p:sp>
+      <p:graphicFrame>
+        <p:nvGraphicFramePr>
+          <p:cNvPr id="4" name="Table 1"/>
+          <p:cNvGraphicFramePr/>
+          <p:nvPr/>
+        </p:nvGraphicFramePr>
+        <a:xfrm>
+          <a:off x="457200" y="1371600"/>
+          <a:ext cx="8229600" cy="5029200"/>
+        </a:xfrm>
+        <a:graphic>
+          <a:graphicData uri="http://schemas.openxmlformats.org/drawingml/2006/table">
+            <a:tbl xmlns:a="http://schemas.openxmlformats.org/drawingml/2006/main">
+              <a:tblPr firstRow="1" bandRow="1">
+                <a:tableStyleId>{5C22544A-7EE6-4342-B048-85BDC9FD1C3A}</a:tableStyleId>
+              </a:tblPr>
+              <a:tblGrid>
+                <a:gridCol w="667264"/>
+                <a:gridCol w="1779372"/>
+                <a:gridCol w="3113902"/>
+                <a:gridCol w="1334529"/>
+                <a:gridCol w="1334529"/>
+              </a:tblGrid>
+              <a:tr h="457200">
+                <a:tc>
+                  <a:txBody>
+                    <a:bodyPr/>
+                    <a:lstStyle/>
+                    <a:p>
+                      <a:pPr algn="l"/>
+                      <a:r>
+                        <a:rPr lang="ru-RU" sz="1100" dirty="0">
+                          <a:b/>
+                        </a:rPr>
+                        <a:t>№</a:t>
+                      </a:r>
+                    </a:p>
+                  </a:txBody>
+                  <a:tcPr/>
+                </a:tc>
+                <a:tc>
+                  <a:txBody>
+                    <a:bodyPr/>
+                    <a:lstStyle/>
+                    <a:p>
+                      <a:pPr algn="l"/>
+                      <a:r>
+                        <a:rPr lang="ru-RU" sz="1100" dirty="0">
+                          <a:b/>
+                        </a:rPr>
+                        <a:t>Название</a:t>
+                      </a:r>
+                    </a:p>
+                  </a:txBody>
+                  <a:tcPr/>
+                </a:tc>
+                <a:tc>
+                  <a:txBody>
+                    <a:bodyPr/>
+                    <a:lstStyle/>
+                    <a:p>
+                      <a:pPr algn="l"/>
+                      <a:r>
+                        <a:rPr lang="ru-RU" sz="1100" dirty="0">
+                          <a:b/>
+                        </a:rPr>
+                        <a:t>Семантика</a:t>
+                      </a:r>
+                    </a:p>
+                  </a:txBody>
+                  <a:tcPr/>
+                </a:tc>
+                <a:tc>
+                  <a:txBody>
+                    <a:bodyPr/>
+                    <a:lstStyle/>
+                    <a:p>
+                      <a:pPr algn="l"/>
+                      <a:r>
+                        <a:rPr lang="ru-RU" sz="1100" dirty="0">
+                          <a:b/>
+                        </a:rPr>
+                        <a:t>Тип</a:t>
+                      </a:r>
+                    </a:p>
+                  </a:txBody>
+                  <a:tcPr/>
+                </a:tc>
+                <a:tc>
+                  <a:txBody>
+                    <a:bodyPr/>
+                    <a:lstStyle/>
+                    <a:p>
+                      <a:pPr algn="l"/>
+                      <a:r>
+                        <a:rPr lang="ru-RU" sz="1100" dirty="0">
+                          <a:b/>
+                        </a:rPr>
+                        <a:t>Значения</a:t>
+                      </a:r>
+                    </a:p>
+                  </a:txBody>
+                  <a:tcPr/>
+                </a:tc>
+              </a:tr>
+              <a:tr h="457200">
+                <a:tc>
+                  <a:txBody>
+                    <a:bodyPr/>
+                    <a:lstStyle/>
+                    <a:p>
+                      <a:pPr algn="l"/>
+                      <a:r>
+                        <a:rPr lang="ru-RU" sz="1000" dirty="0"/>
+                        <a:t>1</a:t>
+                      </a:r>
+                    </a:p>
+                  </a:txBody>
+                  <a:tcPr/>
+                </a:tc>
+                <a:tc>
+                  <a:txBody>
+                    <a:bodyPr/>
+                    <a:lstStyle/>
+                    <a:p>
+                      <a:pPr algn="l"/>
+                      <a:r>
+                        <a:rPr lang="ru-RU" sz="1000" dirty="0"/>
+                        <a:t>year</a:t>
+                      </a:r>
+                    </a:p>
+                  </a:txBody>
+                  <a:tcPr/>
+                </a:tc>
+                <a:tc>
+                  <a:txBody>
+                    <a:bodyPr/>
+                    <a:lstStyle/>
+                    <a:p>
+                      <a:pPr algn="l"/>
+                      <a:r>
+                        <a:rPr lang="ru-RU" sz="1000" dirty="0"/>
+                        <a:t>Год наблюдения</a:t>
+                      </a:r>
+                    </a:p>
+                  </a:txBody>
+                  <a:tcPr/>
+                </a:tc>
+                <a:tc>
+                  <a:txBody>
+                    <a:bodyPr/>
+                    <a:lstStyle/>
+                    <a:p>
+                      <a:pPr algn="l"/>
+                      <a:r>
+                        <a:rPr lang="ru-RU" sz="1000" dirty="0"/>
+                        <a:t>числовой</a:t>
+                      </a:r>
+                    </a:p>
+                  </a:txBody>
+                  <a:tcPr/>
+                </a:tc>
+                <a:tc>
+                  <a:txBody>
+                    <a:bodyPr/>
+                    <a:lstStyle/>
+                    <a:p>
+                      <a:pPr algn="l"/>
+                      <a:r>
+                        <a:rPr lang="ru-RU" sz="1000" dirty="0"/>
+                        <a:t>2015–2021</a:t>
+                      </a:r>
+                    </a:p>
+                  </a:txBody>
+                  <a:tcPr/>
+                </a:tc>
+              </a:tr>
+              <a:tr h="457200">
+                <a:tc>
+                  <a:txBody>
+                    <a:bodyPr/>
+                    <a:lstStyle/>
+                    <a:p>
+                      <a:pPr algn="l"/>
+                      <a:r>
+                        <a:rPr lang="ru-RU" sz="1000" dirty="0"/>
+                        <a:t>2</a:t>
+                      </a:r>
+                    </a:p>
+                  </a:txBody>
+                  <a:tcPr/>
+                </a:tc>
+                <a:tc>
+                  <a:txBody>
+                    <a:bodyPr/>
+                    <a:lstStyle/>
+                    <a:p>
+                      <a:pPr algn="l"/>
+                      <a:r>
+                        <a:rPr lang="ru-RU" sz="1000" dirty="0"/>
+                        <a:t>Country name</a:t>
+                      </a:r>
+                    </a:p>
+                  </a:txBody>
+                  <a:tcPr/>
+                </a:tc>
+                <a:tc>
+                  <a:txBody>
+                    <a:bodyPr/>
+                    <a:lstStyle/>
+                    <a:p>
+                      <a:pPr algn="l"/>
+                      <a:r>
+                        <a:rPr lang="ru-RU" sz="1000" dirty="0"/>
+                        <a:t>Название страны</a:t>
+                      </a:r>
+                    </a:p>
+                  </a:txBody>
+                  <a:tcPr/>
+                </a:tc>
+                <a:tc>
+                  <a:txBody>
+                    <a:bodyPr/>
+                    <a:lstStyle/>
+                    <a:p>
+                      <a:pPr algn="l"/>
+                      <a:r>
+                        <a:rPr lang="ru-RU" sz="1000" dirty="0"/>
+                        <a:t>категор.</a:t>
+                      </a:r>
+                    </a:p>
+                  </a:txBody>
+                  <a:tcPr/>
+                </a:tc>
+                <a:tc>
+                  <a:txBody>
+                    <a:bodyPr/>
+                    <a:lstStyle/>
+                    <a:p>
+                      <a:pPr algn="l"/>
+                      <a:r>
+                        <a:rPr lang="ru-RU" sz="1000" dirty="0"/>
+                        <a:t>149 уник.</a:t>
+                      </a:r>
+                    </a:p>
+                  </a:txBody>
+                  <a:tcPr/>
+                </a:tc>
+              </a:tr>
+              <a:tr h="457200">
+                <a:tc>
+                  <a:txBody>
+                    <a:bodyPr/>
+                    <a:lstStyle/>
+                    <a:p>
+                      <a:pPr algn="l"/>
+                      <a:r>
+                        <a:rPr lang="ru-RU" sz="1000" dirty="0"/>
+                        <a:t>3</a:t>
+                      </a:r>
+                    </a:p>
+                  </a:txBody>
+                  <a:tcPr/>
+                </a:tc>
+                <a:tc>
+                  <a:txBody>
+                    <a:bodyPr/>
+                    <a:lstStyle/>
+                    <a:p>
+                      <a:pPr algn="l"/>
+                      <a:r>
+                        <a:rPr lang="ru-RU" sz="1000" dirty="0"/>
+                        <a:t>Regional indicator</a:t>
+                      </a:r>
+                    </a:p>
+                  </a:txBody>
+                  <a:tcPr/>
+                </a:tc>
+                <a:tc>
+                  <a:txBody>
+                    <a:bodyPr/>
+                    <a:lstStyle/>
+                    <a:p>
+                      <a:pPr algn="l"/>
+                      <a:r>
+                        <a:rPr lang="ru-RU" sz="1000" dirty="0"/>
+                        <a:t>Регион мира</a:t>
+                      </a:r>
+                    </a:p>
+                  </a:txBody>
+                  <a:tcPr/>
+                </a:tc>
+                <a:tc>
+                  <a:txBody>
+                    <a:bodyPr/>
+                    <a:lstStyle/>
+                    <a:p>
+                      <a:pPr algn="l"/>
+                      <a:r>
+                        <a:rPr lang="ru-RU" sz="1000" dirty="0"/>
+                        <a:t>категор.</a:t>
+                      </a:r>
+                    </a:p>
+                  </a:txBody>
+                  <a:tcPr/>
+                </a:tc>
+                <a:tc>
+                  <a:txBody>
+                    <a:bodyPr/>
+                    <a:lstStyle/>
+                    <a:p>
+                      <a:pPr algn="l"/>
+                      <a:r>
+                        <a:rPr lang="ru-RU" sz="1000" dirty="0"/>
+                        <a:t>10 регионов</a:t>
+                      </a:r>
+                    </a:p>
+                  </a:txBody>
+                  <a:tcPr/>
+                </a:tc>
+              </a:tr>
+              <a:tr h="457200">
+                <a:tc>
+                  <a:txBody>
+                    <a:bodyPr/>
+                    <a:lstStyle/>
+                    <a:p>
+                      <a:pPr algn="l"/>
+                      <a:r>
+                        <a:rPr lang="ru-RU" sz="1000" dirty="0"/>
+                        <a:t>4</a:t>
+                      </a:r>
+                    </a:p>
+                  </a:txBody>
+                  <a:tcPr/>
+                </a:tc>
+                <a:tc>
+                  <a:txBody>
+                    <a:bodyPr/>
+                    <a:lstStyle/>
+                    <a:p>
+                      <a:pPr algn="l"/>
+                      <a:r>
+                        <a:rPr lang="ru-RU" sz="1000" dirty="0"/>
+                        <a:t>happiness</a:t>
+                      </a:r>
+                    </a:p>
+                  </a:txBody>
+                  <a:tcPr/>
+                </a:tc>
+                <a:tc>
+                  <a:txBody>
+                    <a:bodyPr/>
+                    <a:lstStyle/>
+                    <a:p>
+                      <a:pPr algn="l"/>
+                      <a:r>
+                        <a:rPr lang="ru-RU" sz="1000" dirty="0"/>
+                        <a:t>Индекс счастья (ЦЕЛЕВАЯ)</a:t>
+                      </a:r>
+                    </a:p>
+                  </a:txBody>
+                  <a:tcPr/>
+                </a:tc>
+                <a:tc>
+                  <a:txBody>
+                    <a:bodyPr/>
+                    <a:lstStyle/>
+                    <a:p>
+                      <a:pPr algn="l"/>
+                      <a:r>
+                        <a:rPr lang="ru-RU" sz="1000" dirty="0"/>
+                        <a:t>числовой</a:t>
+                      </a:r>
+                    </a:p>
+                  </a:txBody>
+                  <a:tcPr/>
+                </a:tc>
+                <a:tc>
+                  <a:txBody>
+                    <a:bodyPr/>
+                    <a:lstStyle/>
+                    <a:p>
+                      <a:pPr algn="l"/>
+                      <a:r>
+                        <a:rPr lang="ru-RU" sz="1000" dirty="0"/>
+                        <a:t>0–10</a:t>
+                      </a:r>
+                    </a:p>
+                  </a:txBody>
+                  <a:tcPr/>
+                </a:tc>
+              </a:tr>
+              <a:tr h="457200">
+                <a:tc>
+                  <a:txBody>
+                    <a:bodyPr/>
+                    <a:lstStyle/>
+                    <a:p>
+                      <a:pPr algn="l"/>
+                      <a:r>
+                        <a:rPr lang="ru-RU" sz="1000" dirty="0"/>
+                        <a:t>5</a:t>
+                      </a:r>
+                    </a:p>
+                  </a:txBody>
+                  <a:tcPr/>
+                </a:tc>
+                <a:tc>
+                  <a:txBody>
+                    <a:bodyPr/>
+                    <a:lstStyle/>
+                    <a:p>
+                      <a:pPr algn="l"/>
+                      <a:r>
+                        <a:rPr lang="ru-RU" sz="1000" dirty="0"/>
+                        <a:t>gdp</a:t>
+                      </a:r>
+                    </a:p>
+                  </a:txBody>
+                  <a:tcPr/>
+                </a:tc>
+                <a:tc>
+                  <a:txBody>
+                    <a:bodyPr/>
+                    <a:lstStyle/>
+                    <a:p>
+                      <a:pPr algn="l"/>
+                      <a:r>
+                        <a:rPr lang="ru-RU" sz="1000" dirty="0"/>
+                        <a:t>ВВП на душу нас. (log)</a:t>
+                      </a:r>
+                    </a:p>
+                  </a:txBody>
+                  <a:tcPr/>
+                </a:tc>
+                <a:tc>
+                  <a:txBody>
+                    <a:bodyPr/>
+                    <a:lstStyle/>
+                    <a:p>
+                      <a:pPr algn="l"/>
+                      <a:r>
+                        <a:rPr lang="ru-RU" sz="1000" dirty="0"/>
+                        <a:t>числовой</a:t>
+                      </a:r>
+                    </a:p>
+                  </a:txBody>
+                  <a:tcPr/>
+                </a:tc>
+                <a:tc>
+                  <a:txBody>
+                    <a:bodyPr/>
+                    <a:lstStyle/>
+                    <a:p>
+                      <a:pPr algn="l"/>
+                      <a:r>
+                        <a:rPr lang="ru-RU" sz="1000" dirty="0"/>
+                        <a:t>6.6–11.6</a:t>
+                      </a:r>
+                    </a:p>
+                  </a:txBody>
+                  <a:tcPr/>
+                </a:tc>
+              </a:tr>
+              <a:tr h="457200">
+                <a:tc>
+                  <a:txBody>
+                    <a:bodyPr/>
+                    <a:lstStyle/>
+                    <a:p>
+                      <a:pPr algn="l"/>
+                      <a:r>
+                        <a:rPr lang="ru-RU" sz="1000" dirty="0"/>
+                        <a:t>6</a:t>
+                      </a:r>
+                    </a:p>
+                  </a:txBody>
+                  <a:tcPr/>
+                </a:tc>
+                <a:tc>
+                  <a:txBody>
+                    <a:bodyPr/>
+                    <a:lstStyle/>
+                    <a:p>
+                      <a:pPr algn="l"/>
+                      <a:r>
+                        <a:rPr lang="ru-RU" sz="1000" dirty="0"/>
+                        <a:t>social_support</a:t>
+                      </a:r>
+                    </a:p>
+                  </a:txBody>
+                  <a:tcPr/>
+                </a:tc>
+                <a:tc>
+                  <a:txBody>
+                    <a:bodyPr/>
+                    <a:lstStyle/>
+                    <a:p>
+                      <a:pPr algn="l"/>
+                      <a:r>
+                        <a:rPr lang="ru-RU" sz="1000" dirty="0"/>
+                        <a:t>Социальная поддержка</a:t>
+                      </a:r>
+                    </a:p>
+                  </a:txBody>
+                  <a:tcPr/>
+                </a:tc>
+                <a:tc>
+                  <a:txBody>
+                    <a:bodyPr/>
+                    <a:lstStyle/>
+                    <a:p>
+                      <a:pPr algn="l"/>
+                      <a:r>
+                        <a:rPr lang="ru-RU" sz="1000" dirty="0"/>
+                        <a:t>числовой</a:t>
+                      </a:r>
+                    </a:p>
+                  </a:txBody>
+                  <a:tcPr/>
+                </a:tc>
+                <a:tc>
+                  <a:txBody>
+                    <a:bodyPr/>
+                    <a:lstStyle/>
+                    <a:p>
+                      <a:pPr algn="l"/>
+                      <a:r>
+                        <a:rPr lang="ru-RU" sz="1000" dirty="0"/>
+                        <a:t>0–1</a:t>
+                      </a:r>
+                    </a:p>
+                  </a:txBody>
+                  <a:tcPr/>
+                </a:tc>
+              </a:tr>
+              <a:tr h="457200">
+                <a:tc>
+                  <a:txBody>
+                    <a:bodyPr/>
+                    <a:lstStyle/>
+                    <a:p>
+                      <a:pPr algn="l"/>
+                      <a:r>
+                        <a:rPr lang="ru-RU" sz="1000" dirty="0"/>
+                        <a:t>7</a:t>
+                      </a:r>
+                    </a:p>
+                  </a:txBody>
+                  <a:tcPr/>
+                </a:tc>
+                <a:tc>
+                  <a:txBody>
+                    <a:bodyPr/>
+                    <a:lstStyle/>
+                    <a:p>
+                      <a:pPr algn="l"/>
+                      <a:r>
+                        <a:rPr lang="ru-RU" sz="1000" dirty="0"/>
+                        <a:t>life_expectancy</a:t>
+                      </a:r>
+                    </a:p>
+                  </a:txBody>
+                  <a:tcPr/>
+                </a:tc>
+                <a:tc>
+                  <a:txBody>
+                    <a:bodyPr/>
+                    <a:lstStyle/>
+                    <a:p>
+                      <a:pPr algn="l"/>
+                      <a:r>
+                        <a:rPr lang="ru-RU" sz="1000" dirty="0"/>
+                        <a:t>Ожид. продолж. здор. жизни</a:t>
+                      </a:r>
+                    </a:p>
+                  </a:txBody>
+                  <a:tcPr/>
+                </a:tc>
+                <a:tc>
+                  <a:txBody>
+                    <a:bodyPr/>
+                    <a:lstStyle/>
+                    <a:p>
+                      <a:pPr algn="l"/>
+                      <a:r>
+                        <a:rPr lang="ru-RU" sz="1000" dirty="0"/>
+                        <a:t>числовой</a:t>
+                      </a:r>
+                    </a:p>
+                  </a:txBody>
+                  <a:tcPr/>
+                </a:tc>
+                <a:tc>
+                  <a:txBody>
+                    <a:bodyPr/>
+                    <a:lstStyle/>
+                    <a:p>
+                      <a:pPr algn="l"/>
+                      <a:r>
+                        <a:rPr lang="ru-RU" sz="1000" dirty="0"/>
+                        <a:t>32–77 лет</a:t>
+                      </a:r>
+                    </a:p>
+                  </a:txBody>
+                  <a:tcPr/>
+                </a:tc>
+              </a:tr>
+              <a:tr h="457200">
+                <a:tc>
+                  <a:txBody>
+                    <a:bodyPr/>
+                    <a:lstStyle/>
+                    <a:p>
+                      <a:pPr algn="l"/>
+                      <a:r>
+                        <a:rPr lang="ru-RU" sz="1000" dirty="0"/>
+                        <a:t>8</a:t>
+                      </a:r>
+                    </a:p>
+                  </a:txBody>
+                  <a:tcPr/>
+                </a:tc>
+                <a:tc>
+                  <a:txBody>
+                    <a:bodyPr/>
+                    <a:lstStyle/>
+                    <a:p>
+                      <a:pPr algn="l"/>
+                      <a:r>
+                        <a:rPr lang="ru-RU" sz="1000" dirty="0"/>
+                        <a:t>freedom</a:t>
+                      </a:r>
+                    </a:p>
+                  </a:txBody>
+                  <a:tcPr/>
+                </a:tc>
+                <a:tc>
+                  <a:txBody>
+                    <a:bodyPr/>
+                    <a:lstStyle/>
+                    <a:p>
+                      <a:pPr algn="l"/>
+                      <a:r>
+                        <a:rPr lang="ru-RU" sz="1000" dirty="0"/>
+                        <a:t>Свобода жизненного выбора</a:t>
+                      </a:r>
+                    </a:p>
+                  </a:txBody>
+                  <a:tcPr/>
+                </a:tc>
+                <a:tc>
+                  <a:txBody>
+                    <a:bodyPr/>
+                    <a:lstStyle/>
+                    <a:p>
+                      <a:pPr algn="l"/>
+                      <a:r>
+                        <a:rPr lang="ru-RU" sz="1000" dirty="0"/>
+                        <a:t>числовой</a:t>
+                      </a:r>
+                    </a:p>
+                  </a:txBody>
+                  <a:tcPr/>
+                </a:tc>
+                <a:tc>
+                  <a:txBody>
+                    <a:bodyPr/>
+                    <a:lstStyle/>
+                    <a:p>
+                      <a:pPr algn="l"/>
+                      <a:r>
+                        <a:rPr lang="ru-RU" sz="1000" dirty="0"/>
+                        <a:t>0–1</a:t>
+                      </a:r>
+                    </a:p>
+                  </a:txBody>
+                  <a:tcPr/>
+                </a:tc>
+              </a:tr>
+              <a:tr h="457200">
+                <a:tc>
+                  <a:txBody>
+                    <a:bodyPr/>
+                    <a:lstStyle/>
+                    <a:p>
+                      <a:pPr algn="l"/>
+                      <a:r>
+                        <a:rPr lang="ru-RU" sz="1000" dirty="0"/>
+                        <a:t>9</a:t>
+                      </a:r>
+                    </a:p>
+                  </a:txBody>
+                  <a:tcPr/>
+                </a:tc>
+                <a:tc>
+                  <a:txBody>
+                    <a:bodyPr/>
+                    <a:lstStyle/>
+                    <a:p>
+                      <a:pPr algn="l"/>
+                      <a:r>
+                        <a:rPr lang="ru-RU" sz="1000" dirty="0"/>
+                        <a:t>generosity</a:t>
+                      </a:r>
+                    </a:p>
+                  </a:txBody>
+                  <a:tcPr/>
+                </a:tc>
+                <a:tc>
+                  <a:txBody>
+                    <a:bodyPr/>
+                    <a:lstStyle/>
+                    <a:p>
+                      <a:pPr algn="l"/>
+                      <a:r>
+                        <a:rPr lang="ru-RU" sz="1000" dirty="0"/>
+                        <a:t>Щедрость</a:t>
+                      </a:r>
+                    </a:p>
+                  </a:txBody>
+                  <a:tcPr/>
+                </a:tc>
+                <a:tc>
+                  <a:txBody>
+                    <a:bodyPr/>
+                    <a:lstStyle/>
+                    <a:p>
+                      <a:pPr algn="l"/>
+                      <a:r>
+                        <a:rPr lang="ru-RU" sz="1000" dirty="0"/>
+                        <a:t>числовой</a:t>
+                      </a:r>
+                    </a:p>
+                  </a:txBody>
+                  <a:tcPr/>
+                </a:tc>
+                <a:tc>
+                  <a:txBody>
+                    <a:bodyPr/>
+                    <a:lstStyle/>
+                    <a:p>
+                      <a:pPr algn="l"/>
+                      <a:r>
+                        <a:rPr lang="ru-RU" sz="1000" dirty="0"/>
+                        <a:t>−0.30–0.70</a:t>
+                      </a:r>
+                    </a:p>
+                  </a:txBody>
+                  <a:tcPr/>
+                </a:tc>
+              </a:tr>
+              <a:tr h="457200">
+                <a:tc>
+                  <a:txBody>
+                    <a:bodyPr/>
+                    <a:lstStyle/>
+                    <a:p>
+                      <a:pPr algn="l"/>
+                      <a:r>
+                        <a:rPr lang="ru-RU" sz="1000" dirty="0"/>
+                        <a:t>10</a:t>
+                      </a:r>
+                    </a:p>
+                  </a:txBody>
+                  <a:tcPr/>
+                </a:tc>
+                <a:tc>
+                  <a:txBody>
+                    <a:bodyPr/>
+                    <a:lstStyle/>
+                    <a:p>
+                      <a:pPr algn="l"/>
+                      <a:r>
+                        <a:rPr lang="ru-RU" sz="1000" dirty="0"/>
+                        <a:t>corruption</a:t>
+                      </a:r>
+                    </a:p>
+                  </a:txBody>
+                  <a:tcPr/>
+                </a:tc>
+                <a:tc>
+                  <a:txBody>
+                    <a:bodyPr/>
+                    <a:lstStyle/>
+                    <a:p>
+                      <a:pPr algn="l"/>
+                      <a:r>
+                        <a:rPr lang="ru-RU" sz="1000" dirty="0"/>
+                        <a:t>Восприятие коррупции</a:t>
+                      </a:r>
+                    </a:p>
+                  </a:txBody>
+                  <a:tcPr/>
+                </a:tc>
+                <a:tc>
+                  <a:txBody>
+                    <a:bodyPr/>
+                    <a:lstStyle/>
+                    <a:p>
+                      <a:pPr algn="l"/>
+                      <a:r>
+                        <a:rPr lang="ru-RU" sz="1000" dirty="0"/>
+                        <a:t>числовой</a:t>
+                      </a:r>
+                    </a:p>
+                  </a:txBody>
+                  <a:tcPr/>
+                </a:tc>
+                <a:tc>
+                  <a:txBody>
+                    <a:bodyPr/>
+                    <a:lstStyle/>
+                    <a:p>
+                      <a:pPr algn="l"/>
+                      <a:r>
+                        <a:rPr lang="ru-RU" sz="1000" dirty="0"/>
+                        <a:t>0–0.65</a:t>
+                      </a:r>
+                    </a:p>
+                  </a:txBody>
+                  <a:tcPr/>
+                </a:tc>
+              </a:tr>
+            </a:tbl>
+          </a:graphicData>
+        </a:graphic>
+      </p:graphicFrame>
+    </p:spTree>
+  </p:cSld>
+  <p:clrMapOvr>
+    <a:masterClrMapping/>
+  </p:clrMapOvr>
+</p:sld>
+</file>
+
+<file path=ppt/slides/slide28.xml><?xml version="1.0" encoding="utf-8"?>
+<p:sld xmlns:a="http://schemas.openxmlformats.org/drawingml/2006/main" xmlns:p="http://schemas.openxmlformats.org/presentationml/2006/main" xmlns:r="http://schemas.openxmlformats.org/officeDocument/2006/relationships">
+  <p:cSld>
+    <p:bg>
+      <p:bgPr>
+        <a:solidFill>
+          <a:srgbClr val="FFFFFF"/>
+        </a:solidFill>
+      </p:bgPr>
+    </p:bg>
+    <p:spTree>
+      <p:nvGrpSpPr>
+        <p:cNvPr id="1" name=""/>
+        <p:cNvGrpSpPr/>
+        <p:nvPr/>
+      </p:nvGrpSpPr>
+      <p:grpSpPr>
+        <a:xfrm>
+          <a:off x="0" y="0"/>
+          <a:ext cx="0" cy="0"/>
+          <a:chOff x="0" y="0"/>
+          <a:chExt cx="0" cy="0"/>
+        </a:xfrm>
+      </p:grpSpPr>
+      <p:sp>
+        <p:nvSpPr>
+          <p:cNvPr id="2" name="title"/>
+          <p:cNvSpPr txBox="1"/>
+          <p:nvPr/>
+        </p:nvSpPr>
+        <p:spPr>
+          <a:xfrm>
+            <a:off x="457200" y="457200"/>
+            <a:ext cx="8229600" cy="685800"/>
+          </a:xfrm>
+          <a:prstGeom prst="rect">
+            <a:avLst/>
+          </a:prstGeom>
+          <a:solidFill>
+            <a:srgbClr val="1F3864"/>
+          </a:solidFill>
+        </p:spPr>
+        <p:txBody>
+          <a:bodyPr wrap="square" rtlCol="0" anchor="ctr" lIns="91440" tIns="45720" rIns="91440" bIns="45720"/>
+          <a:lstStyle/>
+          <a:p>
+            <a:pPr algn="l"/>
+            <a:r>
+              <a:rPr lang="ru-RU" sz="1800" dirty="0">
+                <a:b/>
+                <a:solidFill>
+                  <a:srgbClr val="FFFFFF"/>
+                </a:solidFill>
+              </a:rPr>
+              <a:t>ГЛАВА 1 — ТАБЛИЧНЫЕ   Пример данных (первые строки)</a:t>
+            </a:r>
+          </a:p>
+        </p:txBody>
+      </p:sp>
+      <p:graphicFrame>
+        <p:nvGraphicFramePr>
+          <p:cNvPr id="4" name="Table 1"/>
+          <p:cNvGraphicFramePr/>
+          <p:nvPr/>
+        </p:nvGraphicFramePr>
+        <a:xfrm>
+          <a:off x="457200" y="1371600"/>
+          <a:ext cx="8229600" cy="5029200"/>
+        </a:xfrm>
+        <a:graphic>
+          <a:graphicData uri="http://schemas.openxmlformats.org/drawingml/2006/table">
+            <a:tbl xmlns:a="http://schemas.openxmlformats.org/drawingml/2006/main">
+              <a:tblPr firstRow="1" bandRow="1">
+                <a:tableStyleId>{5C22544A-7EE6-4342-B048-85BDC9FD1C3A}</a:tableStyleId>
+              </a:tblPr>
+              <a:tblGrid>
+                <a:gridCol w="1316736"/>
+                <a:gridCol w="658368"/>
+                <a:gridCol w="987552"/>
+                <a:gridCol w="822960"/>
+                <a:gridCol w="822960"/>
+                <a:gridCol w="987552"/>
+                <a:gridCol w="987552"/>
+                <a:gridCol w="1645920"/>
+              </a:tblGrid>
+              <a:tr h="718457">
+                <a:tc>
+                  <a:txBody>
+                    <a:bodyPr/>
+                    <a:lstStyle/>
+                    <a:p>
+                      <a:pPr algn="l"/>
+                      <a:r>
+                        <a:rPr lang="ru-RU" sz="1100" dirty="0">
+                          <a:b/>
+                        </a:rPr>
+                        <a:t>Country</a:t>
+                      </a:r>
+                    </a:p>
+                  </a:txBody>
+                  <a:tcPr/>
+                </a:tc>
+                <a:tc>
+                  <a:txBody>
+                    <a:bodyPr/>
+                    <a:lstStyle/>
+                    <a:p>
+                      <a:pPr algn="l"/>
+                      <a:r>
+                        <a:rPr lang="ru-RU" sz="1100" dirty="0">
+                          <a:b/>
+                        </a:rPr>
+                        <a:t>year</a:t>
+                      </a:r>
+                    </a:p>
+                  </a:txBody>
+                  <a:tcPr/>
+                </a:tc>
+                <a:tc>
+                  <a:txBody>
+                    <a:bodyPr/>
+                    <a:lstStyle/>
+                    <a:p>
+                      <a:pPr algn="l"/>
+                      <a:r>
+                        <a:rPr lang="ru-RU" sz="1100" dirty="0">
+                          <a:b/>
+                        </a:rPr>
+                        <a:t>happiness</a:t>
+                      </a:r>
+                    </a:p>
+                  </a:txBody>
+                  <a:tcPr/>
+                </a:tc>
+                <a:tc>
+                  <a:txBody>
+                    <a:bodyPr/>
+                    <a:lstStyle/>
+                    <a:p>
+                      <a:pPr algn="l"/>
+                      <a:r>
+                        <a:rPr lang="ru-RU" sz="1100" dirty="0">
+                          <a:b/>
+                        </a:rPr>
+                        <a:t>gdp</a:t>
+                      </a:r>
+                    </a:p>
+                  </a:txBody>
+                  <a:tcPr/>
+                </a:tc>
+                <a:tc>
+                  <a:txBody>
+                    <a:bodyPr/>
+                    <a:lstStyle/>
+                    <a:p>
+                      <a:pPr algn="l"/>
+                      <a:r>
+                        <a:rPr lang="ru-RU" sz="1100" dirty="0">
+                          <a:b/>
+                        </a:rPr>
+                        <a:t>social</a:t>
+                      </a:r>
+                    </a:p>
+                  </a:txBody>
+                  <a:tcPr/>
+                </a:tc>
+                <a:tc>
+                  <a:txBody>
+                    <a:bodyPr/>
+                    <a:lstStyle/>
+                    <a:p>
+                      <a:pPr algn="l"/>
+                      <a:r>
+                        <a:rPr lang="ru-RU" sz="1100" dirty="0">
+                          <a:b/>
+                        </a:rPr>
+                        <a:t>life_exp</a:t>
+                      </a:r>
+                    </a:p>
+                  </a:txBody>
+                  <a:tcPr/>
+                </a:tc>
+                <a:tc>
+                  <a:txBody>
+                    <a:bodyPr/>
+                    <a:lstStyle/>
+                    <a:p>
+                      <a:pPr algn="l"/>
+                      <a:r>
+                        <a:rPr lang="ru-RU" sz="1100" dirty="0">
+                          <a:b/>
+                        </a:rPr>
+                        <a:t>freedom</a:t>
+                      </a:r>
+                    </a:p>
+                  </a:txBody>
+                  <a:tcPr/>
+                </a:tc>
+                <a:tc>
+                  <a:txBody>
+                    <a:bodyPr/>
+                    <a:lstStyle/>
+                    <a:p>
+                      <a:pPr algn="l"/>
+                      <a:r>
+                        <a:rPr lang="ru-RU" sz="1100" dirty="0">
+                          <a:b/>
+                        </a:rPr>
+                        <a:t>region</a:t>
+                      </a:r>
+                    </a:p>
+                  </a:txBody>
+                  <a:tcPr/>
+                </a:tc>
+              </a:tr>
+              <a:tr h="718457">
+                <a:tc>
+                  <a:txBody>
+                    <a:bodyPr/>
+                    <a:lstStyle/>
+                    <a:p>
+                      <a:pPr algn="l"/>
+                      <a:r>
+                        <a:rPr lang="ru-RU" sz="1000" dirty="0"/>
+                        <a:t>Finland</a:t>
+                      </a:r>
+                    </a:p>
+                  </a:txBody>
+                  <a:tcPr/>
+                </a:tc>
+                <a:tc>
+                  <a:txBody>
+                    <a:bodyPr/>
+                    <a:lstStyle/>
+                    <a:p>
+                      <a:pPr algn="l"/>
+                      <a:r>
+                        <a:rPr lang="ru-RU" sz="1000" dirty="0"/>
+                        <a:t>2021</a:t>
+                      </a:r>
+                    </a:p>
+                  </a:txBody>
+                  <a:tcPr/>
+                </a:tc>
+                <a:tc>
+                  <a:txBody>
+                    <a:bodyPr/>
+                    <a:lstStyle/>
+                    <a:p>
+                      <a:pPr algn="l"/>
+                      <a:r>
+                        <a:rPr lang="ru-RU" sz="1000" dirty="0"/>
+                        <a:t>7.84</a:t>
+                      </a:r>
+                    </a:p>
+                  </a:txBody>
+                  <a:tcPr/>
+                </a:tc>
+                <a:tc>
+                  <a:txBody>
+                    <a:bodyPr/>
+                    <a:lstStyle/>
+                    <a:p>
+                      <a:pPr algn="l"/>
+                      <a:r>
+                        <a:rPr lang="ru-RU" sz="1000" dirty="0"/>
+                        <a:t>10.78</a:t>
+                      </a:r>
+                    </a:p>
+                  </a:txBody>
+                  <a:tcPr/>
+                </a:tc>
+                <a:tc>
+                  <a:txBody>
+                    <a:bodyPr/>
+                    <a:lstStyle/>
+                    <a:p>
+                      <a:pPr algn="l"/>
+                      <a:r>
+                        <a:rPr lang="ru-RU" sz="1000" dirty="0"/>
+                        <a:t>0.954</a:t>
+                      </a:r>
+                    </a:p>
+                  </a:txBody>
+                  <a:tcPr/>
+                </a:tc>
+                <a:tc>
+                  <a:txBody>
+                    <a:bodyPr/>
+                    <a:lstStyle/>
+                    <a:p>
+                      <a:pPr algn="l"/>
+                      <a:r>
+                        <a:rPr lang="ru-RU" sz="1000" dirty="0"/>
+                        <a:t>71.9</a:t>
+                      </a:r>
+                    </a:p>
+                  </a:txBody>
+                  <a:tcPr/>
+                </a:tc>
+                <a:tc>
+                  <a:txBody>
+                    <a:bodyPr/>
+                    <a:lstStyle/>
+                    <a:p>
+                      <a:pPr algn="l"/>
+                      <a:r>
+                        <a:rPr lang="ru-RU" sz="1000" dirty="0"/>
+                        <a:t>0.949</a:t>
+                      </a:r>
+                    </a:p>
+                  </a:txBody>
+                  <a:tcPr/>
+                </a:tc>
+                <a:tc>
+                  <a:txBody>
+                    <a:bodyPr/>
+                    <a:lstStyle/>
+                    <a:p>
+                      <a:pPr algn="l"/>
+                      <a:r>
+                        <a:rPr lang="ru-RU" sz="1000" dirty="0"/>
+                        <a:t>Western Europe</a:t>
+                      </a:r>
+                    </a:p>
+                  </a:txBody>
+                  <a:tcPr/>
+                </a:tc>
+              </a:tr>
+              <a:tr h="718457">
+                <a:tc>
+                  <a:txBody>
+                    <a:bodyPr/>
+                    <a:lstStyle/>
+                    <a:p>
+                      <a:pPr algn="l"/>
+                      <a:r>
+                        <a:rPr lang="ru-RU" sz="1000" dirty="0"/>
+                        <a:t>Iceland</a:t>
+                      </a:r>
+                    </a:p>
+                  </a:txBody>
+                  <a:tcPr/>
+                </a:tc>
+                <a:tc>
+                  <a:txBody>
+                    <a:bodyPr/>
+                    <a:lstStyle/>
+                    <a:p>
+                      <a:pPr algn="l"/>
+                      <a:r>
+                        <a:rPr lang="ru-RU" sz="1000" dirty="0"/>
+                        <a:t>2021</a:t>
+                      </a:r>
+                    </a:p>
+                  </a:txBody>
+                  <a:tcPr/>
+                </a:tc>
+                <a:tc>
+                  <a:txBody>
+                    <a:bodyPr/>
+                    <a:lstStyle/>
+                    <a:p>
+                      <a:pPr algn="l"/>
+                      <a:r>
+                        <a:rPr lang="ru-RU" sz="1000" dirty="0"/>
+                        <a:t>7.55</a:t>
+                      </a:r>
+                    </a:p>
+                  </a:txBody>
+                  <a:tcPr/>
+                </a:tc>
+                <a:tc>
+                  <a:txBody>
+                    <a:bodyPr/>
+                    <a:lstStyle/>
+                    <a:p>
+                      <a:pPr algn="l"/>
+                      <a:r>
+                        <a:rPr lang="ru-RU" sz="1000" dirty="0"/>
+                        <a:t>10.88</a:t>
+                      </a:r>
+                    </a:p>
+                  </a:txBody>
+                  <a:tcPr/>
+                </a:tc>
+                <a:tc>
+                  <a:txBody>
+                    <a:bodyPr/>
+                    <a:lstStyle/>
+                    <a:p>
+                      <a:pPr algn="l"/>
+                      <a:r>
+                        <a:rPr lang="ru-RU" sz="1000" dirty="0"/>
+                        <a:t>0.983</a:t>
+                      </a:r>
+                    </a:p>
+                  </a:txBody>
+                  <a:tcPr/>
+                </a:tc>
+                <a:tc>
+                  <a:txBody>
+                    <a:bodyPr/>
+                    <a:lstStyle/>
+                    <a:p>
+                      <a:pPr algn="l"/>
+                      <a:r>
+                        <a:rPr lang="ru-RU" sz="1000" dirty="0"/>
+                        <a:t>73.0</a:t>
+                      </a:r>
+                    </a:p>
+                  </a:txBody>
+                  <a:tcPr/>
+                </a:tc>
+                <a:tc>
+                  <a:txBody>
+                    <a:bodyPr/>
+                    <a:lstStyle/>
+                    <a:p>
+                      <a:pPr algn="l"/>
+                      <a:r>
+                        <a:rPr lang="ru-RU" sz="1000" dirty="0"/>
+                        <a:t>0.974</a:t>
+                      </a:r>
+                    </a:p>
+                  </a:txBody>
+                  <a:tcPr/>
+                </a:tc>
+                <a:tc>
+                  <a:txBody>
+                    <a:bodyPr/>
+                    <a:lstStyle/>
+                    <a:p>
+                      <a:pPr algn="l"/>
+                      <a:r>
+                        <a:rPr lang="ru-RU" sz="1000" dirty="0"/>
+                        <a:t>Western Europe</a:t>
+                      </a:r>
+                    </a:p>
+                  </a:txBody>
+                  <a:tcPr/>
+                </a:tc>
+              </a:tr>
+              <a:tr h="718457">
+                <a:tc>
+                  <a:txBody>
+                    <a:bodyPr/>
+                    <a:lstStyle/>
+                    <a:p>
+                      <a:pPr algn="l"/>
+                      <a:r>
+                        <a:rPr lang="ru-RU" sz="1000" dirty="0"/>
+                        <a:t>Denmark</a:t>
+                      </a:r>
+                    </a:p>
+                  </a:txBody>
+                  <a:tcPr/>
+                </a:tc>
+                <a:tc>
+                  <a:txBody>
+                    <a:bodyPr/>
+                    <a:lstStyle/>
+                    <a:p>
+                      <a:pPr algn="l"/>
+                      <a:r>
+                        <a:rPr lang="ru-RU" sz="1000" dirty="0"/>
+                        <a:t>2021</a:t>
+                      </a:r>
+                    </a:p>
+                  </a:txBody>
+                  <a:tcPr/>
+                </a:tc>
+                <a:tc>
+                  <a:txBody>
+                    <a:bodyPr/>
+                    <a:lstStyle/>
+                    <a:p>
+                      <a:pPr algn="l"/>
+                      <a:r>
+                        <a:rPr lang="ru-RU" sz="1000" dirty="0"/>
+                        <a:t>7.52</a:t>
+                      </a:r>
+                    </a:p>
+                  </a:txBody>
+                  <a:tcPr/>
+                </a:tc>
+                <a:tc>
+                  <a:txBody>
+                    <a:bodyPr/>
+                    <a:lstStyle/>
+                    <a:p>
+                      <a:pPr algn="l"/>
+                      <a:r>
+                        <a:rPr lang="ru-RU" sz="1000" dirty="0"/>
+                        <a:t>10.93</a:t>
+                      </a:r>
+                    </a:p>
+                  </a:txBody>
+                  <a:tcPr/>
+                </a:tc>
+                <a:tc>
+                  <a:txBody>
+                    <a:bodyPr/>
+                    <a:lstStyle/>
+                    <a:p>
+                      <a:pPr algn="l"/>
+                      <a:r>
+                        <a:rPr lang="ru-RU" sz="1000" dirty="0"/>
+                        <a:t>0.954</a:t>
+                      </a:r>
+                    </a:p>
+                  </a:txBody>
+                  <a:tcPr/>
+                </a:tc>
+                <a:tc>
+                  <a:txBody>
+                    <a:bodyPr/>
+                    <a:lstStyle/>
+                    <a:p>
+                      <a:pPr algn="l"/>
+                      <a:r>
+                        <a:rPr lang="ru-RU" sz="1000" dirty="0"/>
+                        <a:t>72.7</a:t>
+                      </a:r>
+                    </a:p>
+                  </a:txBody>
+                  <a:tcPr/>
+                </a:tc>
+                <a:tc>
+                  <a:txBody>
+                    <a:bodyPr/>
+                    <a:lstStyle/>
+                    <a:p>
+                      <a:pPr algn="l"/>
+                      <a:r>
+                        <a:rPr lang="ru-RU" sz="1000" dirty="0"/>
+                        <a:t>0.946</a:t>
+                      </a:r>
+                    </a:p>
+                  </a:txBody>
+                  <a:tcPr/>
+                </a:tc>
+                <a:tc>
+                  <a:txBody>
+                    <a:bodyPr/>
+                    <a:lstStyle/>
+                    <a:p>
+                      <a:pPr algn="l"/>
+                      <a:r>
+                        <a:rPr lang="ru-RU" sz="1000" dirty="0"/>
+                        <a:t>Western Europe</a:t>
+                      </a:r>
+                    </a:p>
+                  </a:txBody>
+                  <a:tcPr/>
+                </a:tc>
+              </a:tr>
+              <a:tr h="718457">
+                <a:tc>
+                  <a:txBody>
+                    <a:bodyPr/>
+                    <a:lstStyle/>
+                    <a:p>
+                      <a:pPr algn="l"/>
+                      <a:r>
+                        <a:rPr lang="ru-RU" sz="1000" dirty="0"/>
+                        <a:t>Afghanistan</a:t>
+                      </a:r>
+                    </a:p>
+                  </a:txBody>
+                  <a:tcPr/>
+                </a:tc>
+                <a:tc>
+                  <a:txBody>
+                    <a:bodyPr/>
+                    <a:lstStyle/>
+                    <a:p>
+                      <a:pPr algn="l"/>
+                      <a:r>
+                        <a:rPr lang="ru-RU" sz="1000" dirty="0"/>
+                        <a:t>2021</a:t>
+                      </a:r>
+                    </a:p>
+                  </a:txBody>
+                  <a:tcPr/>
+                </a:tc>
+                <a:tc>
+                  <a:txBody>
+                    <a:bodyPr/>
+                    <a:lstStyle/>
+                    <a:p>
+                      <a:pPr algn="l"/>
+                      <a:r>
+                        <a:rPr lang="ru-RU" sz="1000" dirty="0"/>
+                        <a:t>2.52</a:t>
+                      </a:r>
+                    </a:p>
+                  </a:txBody>
+                  <a:tcPr/>
+                </a:tc>
+                <a:tc>
+                  <a:txBody>
+                    <a:bodyPr/>
+                    <a:lstStyle/>
+                    <a:p>
+                      <a:pPr algn="l"/>
+                      <a:r>
+                        <a:rPr lang="ru-RU" sz="1000" dirty="0"/>
+                        <a:t>7.32</a:t>
+                      </a:r>
+                    </a:p>
+                  </a:txBody>
+                  <a:tcPr/>
+                </a:tc>
+                <a:tc>
+                  <a:txBody>
+                    <a:bodyPr/>
+                    <a:lstStyle/>
+                    <a:p>
+                      <a:pPr algn="l"/>
+                      <a:r>
+                        <a:rPr lang="ru-RU" sz="1000" dirty="0"/>
+                        <a:t>0.559</a:t>
+                      </a:r>
+                    </a:p>
+                  </a:txBody>
+                  <a:tcPr/>
+                </a:tc>
+                <a:tc>
+                  <a:txBody>
+                    <a:bodyPr/>
+                    <a:lstStyle/>
+                    <a:p>
+                      <a:pPr algn="l"/>
+                      <a:r>
+                        <a:rPr lang="ru-RU" sz="1000" dirty="0"/>
+                        <a:t>52.4</a:t>
+                      </a:r>
+                    </a:p>
+                  </a:txBody>
+                  <a:tcPr/>
+                </a:tc>
+                <a:tc>
+                  <a:txBody>
+                    <a:bodyPr/>
+                    <a:lstStyle/>
+                    <a:p>
+                      <a:pPr algn="l"/>
+                      <a:r>
+                        <a:rPr lang="ru-RU" sz="1000" dirty="0"/>
+                        <a:t>0.382</a:t>
+                      </a:r>
+                    </a:p>
+                  </a:txBody>
+                  <a:tcPr/>
+                </a:tc>
+                <a:tc>
+                  <a:txBody>
+                    <a:bodyPr/>
+                    <a:lstStyle/>
+                    <a:p>
+                      <a:pPr algn="l"/>
+                      <a:r>
+                        <a:rPr lang="ru-RU" sz="1000" dirty="0"/>
+                        <a:t>South Asia</a:t>
+                      </a:r>
+                    </a:p>
+                  </a:txBody>
+                  <a:tcPr/>
+                </a:tc>
+              </a:tr>
+              <a:tr h="718457">
+                <a:tc>
+                  <a:txBody>
+                    <a:bodyPr/>
+                    <a:lstStyle/>
+                    <a:p>
+                      <a:pPr algn="l"/>
+                      <a:r>
+                        <a:rPr lang="ru-RU" sz="1000" dirty="0"/>
+                        <a:t>Finland</a:t>
+                      </a:r>
+                    </a:p>
+                  </a:txBody>
+                  <a:tcPr/>
+                </a:tc>
+                <a:tc>
+                  <a:txBody>
+                    <a:bodyPr/>
+                    <a:lstStyle/>
+                    <a:p>
+                      <a:pPr algn="l"/>
+                      <a:r>
+                        <a:rPr lang="ru-RU" sz="1000" dirty="0"/>
+                        <a:t>2020</a:t>
+                      </a:r>
+                    </a:p>
+                  </a:txBody>
+                  <a:tcPr/>
+                </a:tc>
+                <a:tc>
+                  <a:txBody>
+                    <a:bodyPr/>
+                    <a:lstStyle/>
+                    <a:p>
+                      <a:pPr algn="l"/>
+                      <a:r>
+                        <a:rPr lang="ru-RU" sz="1000" dirty="0"/>
+                        <a:t>7.81</a:t>
+                      </a:r>
+                    </a:p>
+                  </a:txBody>
+                  <a:tcPr/>
+                </a:tc>
+                <a:tc>
+                  <a:txBody>
+                    <a:bodyPr/>
+                    <a:lstStyle/>
+                    <a:p>
+                      <a:pPr algn="l"/>
+                      <a:r>
+                        <a:rPr lang="ru-RU" sz="1000" dirty="0"/>
+                        <a:t>10.76</a:t>
+                      </a:r>
+                    </a:p>
+                  </a:txBody>
+                  <a:tcPr/>
+                </a:tc>
+                <a:tc>
+                  <a:txBody>
+                    <a:bodyPr/>
+                    <a:lstStyle/>
+                    <a:p>
+                      <a:pPr algn="l"/>
+                      <a:r>
+                        <a:rPr lang="ru-RU" sz="1000" dirty="0"/>
+                        <a:t>0.960</a:t>
+                      </a:r>
+                    </a:p>
+                  </a:txBody>
+                  <a:tcPr/>
+                </a:tc>
+                <a:tc>
+                  <a:txBody>
+                    <a:bodyPr/>
+                    <a:lstStyle/>
+                    <a:p>
+                      <a:pPr algn="l"/>
+                      <a:r>
+                        <a:rPr lang="ru-RU" sz="1000" dirty="0"/>
+                        <a:t>71.7</a:t>
+                      </a:r>
+                    </a:p>
+                  </a:txBody>
+                  <a:tcPr/>
+                </a:tc>
+                <a:tc>
+                  <a:txBody>
+                    <a:bodyPr/>
+                    <a:lstStyle/>
+                    <a:p>
+                      <a:pPr algn="l"/>
+                      <a:r>
+                        <a:rPr lang="ru-RU" sz="1000" dirty="0"/>
+                        <a:t>0.944</a:t>
+                      </a:r>
+                    </a:p>
+                  </a:txBody>
+                  <a:tcPr/>
+                </a:tc>
+                <a:tc>
+                  <a:txBody>
+                    <a:bodyPr/>
+                    <a:lstStyle/>
+                    <a:p>
+                      <a:pPr algn="l"/>
+                      <a:r>
+                        <a:rPr lang="ru-RU" sz="1000" dirty="0"/>
+                        <a:t>Western Europe</a:t>
+                      </a:r>
+                    </a:p>
+                  </a:txBody>
+                  <a:tcPr/>
+                </a:tc>
+              </a:tr>
+              <a:tr h="718457">
+                <a:tc>
+                  <a:txBody>
+                    <a:bodyPr/>
+                    <a:lstStyle/>
+                    <a:p>
+                      <a:pPr algn="l"/>
+                      <a:r>
+                        <a:rPr lang="ru-RU" sz="1000" dirty="0"/>
+                        <a:t>...</a:t>
+                      </a:r>
+                    </a:p>
+                  </a:txBody>
+                  <a:tcPr/>
+                </a:tc>
+                <a:tc>
+                  <a:txBody>
+                    <a:bodyPr/>
+                    <a:lstStyle/>
+                    <a:p>
+                      <a:pPr algn="l"/>
+                      <a:r>
+                        <a:rPr lang="ru-RU" sz="1000" dirty="0"/>
+                        <a:t>...</a:t>
+                      </a:r>
+                    </a:p>
+                  </a:txBody>
+                  <a:tcPr/>
+                </a:tc>
+                <a:tc>
+                  <a:txBody>
+                    <a:bodyPr/>
+                    <a:lstStyle/>
+                    <a:p>
+                      <a:pPr algn="l"/>
+                      <a:r>
+                        <a:rPr lang="ru-RU" sz="1000" dirty="0"/>
+                        <a:t>...</a:t>
+                      </a:r>
+                    </a:p>
+                  </a:txBody>
+                  <a:tcPr/>
+                </a:tc>
+                <a:tc>
+                  <a:txBody>
+                    <a:bodyPr/>
+                    <a:lstStyle/>
+                    <a:p>
+                      <a:pPr algn="l"/>
+                      <a:r>
+                        <a:rPr lang="ru-RU" sz="1000" dirty="0"/>
+                        <a:t>...</a:t>
+                      </a:r>
+                    </a:p>
+                  </a:txBody>
+                  <a:tcPr/>
+                </a:tc>
+                <a:tc>
+                  <a:txBody>
+                    <a:bodyPr/>
+                    <a:lstStyle/>
+                    <a:p>
+                      <a:pPr algn="l"/>
+                      <a:r>
+                        <a:rPr lang="ru-RU" sz="1000" dirty="0"/>
+                        <a:t>...</a:t>
+                      </a:r>
+                    </a:p>
+                  </a:txBody>
+                  <a:tcPr/>
+                </a:tc>
+                <a:tc>
+                  <a:txBody>
+                    <a:bodyPr/>
+                    <a:lstStyle/>
+                    <a:p>
+                      <a:pPr algn="l"/>
+                      <a:r>
+                        <a:rPr lang="ru-RU" sz="1000" dirty="0"/>
+                        <a:t>...</a:t>
+                      </a:r>
+                    </a:p>
+                  </a:txBody>
+                  <a:tcPr/>
+                </a:tc>
+                <a:tc>
+                  <a:txBody>
+                    <a:bodyPr/>
+                    <a:lstStyle/>
+                    <a:p>
+                      <a:pPr algn="l"/>
+                      <a:r>
+                        <a:rPr lang="ru-RU" sz="1000" dirty="0"/>
+                        <a:t>...</a:t>
+                      </a:r>
+                    </a:p>
+                  </a:txBody>
+                  <a:tcPr/>
+                </a:tc>
+                <a:tc>
+                  <a:txBody>
+                    <a:bodyPr/>
+                    <a:lstStyle/>
+                    <a:p>
+                      <a:pPr algn="l"/>
+                      <a:r>
+                        <a:rPr lang="ru-RU" sz="1000" dirty="0"/>
+                        <a:t>...</a:t>
+                      </a:r>
+                    </a:p>
+                  </a:txBody>
+                  <a:tcPr/>
+                </a:tc>
+              </a:tr>
+            </a:tbl>
+          </a:graphicData>
+        </a:graphic>
+      </p:graphicFrame>
+    </p:spTree>
+  </p:cSld>
+  <p:clrMapOvr>
+    <a:masterClrMapping/>
+  </p:clrMapOvr>
+</p:sld>
+</file>
+
+<file path=ppt/slides/slide29.xml><?xml version="1.0" encoding="utf-8"?>
+<p:sld xmlns:a="http://schemas.openxmlformats.org/drawingml/2006/main" xmlns:p="http://schemas.openxmlformats.org/presentationml/2006/main" xmlns:r="http://schemas.openxmlformats.org/officeDocument/2006/relationships">
+  <p:cSld>
+    <p:bg>
+      <p:bgPr>
+        <a:solidFill>
+          <a:srgbClr val="FFFFFF"/>
+        </a:solidFill>
+      </p:bgPr>
+    </p:bg>
+    <p:spTree>
+      <p:nvGrpSpPr>
+        <p:cNvPr id="1" name=""/>
+        <p:cNvGrpSpPr/>
+        <p:nvPr/>
+      </p:nvGrpSpPr>
+      <p:grpSpPr>
+        <a:xfrm>
+          <a:off x="0" y="0"/>
+          <a:ext cx="0" cy="0"/>
+          <a:chOff x="0" y="0"/>
+          <a:chExt cx="0" cy="0"/>
+        </a:xfrm>
+      </p:grpSpPr>
+      <p:sp>
+        <p:nvSpPr>
+          <p:cNvPr id="2" name="title"/>
+          <p:cNvSpPr txBox="1"/>
+          <p:nvPr/>
+        </p:nvSpPr>
+        <p:spPr>
+          <a:xfrm>
+            <a:off x="457200" y="457200"/>
+            <a:ext cx="8229600" cy="685800"/>
+          </a:xfrm>
+          <a:prstGeom prst="rect">
+            <a:avLst/>
+          </a:prstGeom>
+          <a:solidFill>
+            <a:srgbClr val="1F3864"/>
+          </a:solidFill>
+        </p:spPr>
+        <p:txBody>
+          <a:bodyPr wrap="square" rtlCol="0" anchor="ctr" lIns="91440" tIns="45720" rIns="91440" bIns="45720"/>
+          <a:lstStyle/>
+          <a:p>
+            <a:pPr algn="l"/>
+            <a:r>
+              <a:rPr lang="ru-RU" sz="1800" dirty="0">
+                <a:b/>
+                <a:solidFill>
+                  <a:srgbClr val="FFFFFF"/>
+                </a:solidFill>
+              </a:rPr>
+              <a:t>ГЛАВА 2 — ВРЕМЕННЫЕ РЯДЫ   Атрибуты датасета Power Consumption of Tetouan City</a:t>
+            </a:r>
+          </a:p>
+        </p:txBody>
+      </p:sp>
+      <p:graphicFrame>
+        <p:nvGraphicFramePr>
+          <p:cNvPr id="4" name="Table 1"/>
+          <p:cNvGraphicFramePr/>
+          <p:nvPr/>
+        </p:nvGraphicFramePr>
+        <a:xfrm>
+          <a:off x="457200" y="1371600"/>
+          <a:ext cx="8229600" cy="5029200"/>
+        </a:xfrm>
+        <a:graphic>
+          <a:graphicData uri="http://schemas.openxmlformats.org/drawingml/2006/table">
+            <a:tbl xmlns:a="http://schemas.openxmlformats.org/drawingml/2006/main">
+              <a:tblPr firstRow="1" bandRow="1">
+                <a:tableStyleId>{5C22544A-7EE6-4342-B048-85BDC9FD1C3A}</a:tableStyleId>
+              </a:tblPr>
+              <a:tblGrid>
+                <a:gridCol w="602165"/>
+                <a:gridCol w="2007219"/>
+                <a:gridCol w="2408663"/>
+                <a:gridCol w="1204331"/>
+                <a:gridCol w="2007219"/>
+              </a:tblGrid>
+              <a:tr h="502920">
+                <a:tc>
+                  <a:txBody>
+                    <a:bodyPr/>
+                    <a:lstStyle/>
+                    <a:p>
+                      <a:pPr algn="l"/>
+                      <a:r>
+                        <a:rPr lang="ru-RU" sz="1100" dirty="0">
+                          <a:b/>
+                        </a:rPr>
+                        <a:t>№</a:t>
+                      </a:r>
+                    </a:p>
+                  </a:txBody>
+                  <a:tcPr/>
+                </a:tc>
+                <a:tc>
+                  <a:txBody>
+                    <a:bodyPr/>
+                    <a:lstStyle/>
+                    <a:p>
+                      <a:pPr algn="l"/>
+                      <a:r>
+                        <a:rPr lang="ru-RU" sz="1100" dirty="0">
+                          <a:b/>
+                        </a:rPr>
+                        <a:t>Название</a:t>
+                      </a:r>
+                    </a:p>
+                  </a:txBody>
+                  <a:tcPr/>
+                </a:tc>
+                <a:tc>
+                  <a:txBody>
+                    <a:bodyPr/>
+                    <a:lstStyle/>
+                    <a:p>
+                      <a:pPr algn="l"/>
+                      <a:r>
+                        <a:rPr lang="ru-RU" sz="1100" dirty="0">
+                          <a:b/>
+                        </a:rPr>
+                        <a:t>Семантика</a:t>
+                      </a:r>
+                    </a:p>
+                  </a:txBody>
+                  <a:tcPr/>
+                </a:tc>
+                <a:tc>
+                  <a:txBody>
+                    <a:bodyPr/>
+                    <a:lstStyle/>
+                    <a:p>
+                      <a:pPr algn="l"/>
+                      <a:r>
+                        <a:rPr lang="ru-RU" sz="1100" dirty="0">
+                          <a:b/>
+                        </a:rPr>
+                        <a:t>Тип</a:t>
+                      </a:r>
+                    </a:p>
+                  </a:txBody>
+                  <a:tcPr/>
+                </a:tc>
+                <a:tc>
+                  <a:txBody>
+                    <a:bodyPr/>
+                    <a:lstStyle/>
+                    <a:p>
+                      <a:pPr algn="l"/>
+                      <a:r>
+                        <a:rPr lang="ru-RU" sz="1100" dirty="0">
+                          <a:b/>
+                        </a:rPr>
+                        <a:t>Диапазон</a:t>
+                      </a:r>
+                    </a:p>
+                  </a:txBody>
+                  <a:tcPr/>
+                </a:tc>
+              </a:tr>
+              <a:tr h="502920">
+                <a:tc>
+                  <a:txBody>
+                    <a:bodyPr/>
+                    <a:lstStyle/>
+                    <a:p>
+                      <a:pPr algn="l"/>
+                      <a:r>
+                        <a:rPr lang="ru-RU" sz="1000" dirty="0"/>
+                        <a:t>1</a:t>
+                      </a:r>
+                    </a:p>
+                  </a:txBody>
+                  <a:tcPr/>
+                </a:tc>
+                <a:tc>
+                  <a:txBody>
+                    <a:bodyPr/>
+                    <a:lstStyle/>
+                    <a:p>
+                      <a:pPr algn="l"/>
+                      <a:r>
+                        <a:rPr lang="ru-RU" sz="1000" dirty="0"/>
+                        <a:t>Datetime</a:t>
+                      </a:r>
+                    </a:p>
+                  </a:txBody>
+                  <a:tcPr/>
+                </a:tc>
+                <a:tc>
+                  <a:txBody>
+                    <a:bodyPr/>
+                    <a:lstStyle/>
+                    <a:p>
+                      <a:pPr algn="l"/>
+                      <a:r>
+                        <a:rPr lang="ru-RU" sz="1000" dirty="0"/>
+                        <a:t>Метка времени</a:t>
+                      </a:r>
+                    </a:p>
+                  </a:txBody>
+                  <a:tcPr/>
+                </a:tc>
+                <a:tc>
+                  <a:txBody>
+                    <a:bodyPr/>
+                    <a:lstStyle/>
+                    <a:p>
+                      <a:pPr algn="l"/>
+                      <a:r>
+                        <a:rPr lang="ru-RU" sz="1000" dirty="0"/>
+                        <a:t>datetime</a:t>
+                      </a:r>
+                    </a:p>
+                  </a:txBody>
+                  <a:tcPr/>
+                </a:tc>
+                <a:tc>
+                  <a:txBody>
+                    <a:bodyPr/>
+                    <a:lstStyle/>
+                    <a:p>
+                      <a:pPr algn="l"/>
+                      <a:r>
+                        <a:rPr lang="ru-RU" sz="1000" dirty="0"/>
+                        <a:t>2017-01-01..2017-12-30</a:t>
+                      </a:r>
+                    </a:p>
+                  </a:txBody>
+                  <a:tcPr/>
+                </a:tc>
+              </a:tr>
+              <a:tr h="502920">
+                <a:tc>
+                  <a:txBody>
+                    <a:bodyPr/>
+                    <a:lstStyle/>
+                    <a:p>
+                      <a:pPr algn="l"/>
+                      <a:r>
+                        <a:rPr lang="ru-RU" sz="1000" dirty="0"/>
+                        <a:t>2</a:t>
+                      </a:r>
+                    </a:p>
+                  </a:txBody>
+                  <a:tcPr/>
+                </a:tc>
+                <a:tc>
+                  <a:txBody>
+                    <a:bodyPr/>
+                    <a:lstStyle/>
+                    <a:p>
+                      <a:pPr algn="l"/>
+                      <a:r>
+                        <a:rPr lang="ru-RU" sz="1000" dirty="0"/>
+                        <a:t>Temperature</a:t>
+                      </a:r>
+                    </a:p>
+                  </a:txBody>
+                  <a:tcPr/>
+                </a:tc>
+                <a:tc>
+                  <a:txBody>
+                    <a:bodyPr/>
+                    <a:lstStyle/>
+                    <a:p>
+                      <a:pPr algn="l"/>
+                      <a:r>
+                        <a:rPr lang="ru-RU" sz="1000" dirty="0"/>
+                        <a:t>Температура воздуха</a:t>
+                      </a:r>
+                    </a:p>
+                  </a:txBody>
+                  <a:tcPr/>
+                </a:tc>
+                <a:tc>
+                  <a:txBody>
+                    <a:bodyPr/>
+                    <a:lstStyle/>
+                    <a:p>
+                      <a:pPr algn="l"/>
+                      <a:r>
+                        <a:rPr lang="ru-RU" sz="1000" dirty="0"/>
+                        <a:t>числовой</a:t>
+                      </a:r>
+                    </a:p>
+                  </a:txBody>
+                  <a:tcPr/>
+                </a:tc>
+                <a:tc>
+                  <a:txBody>
+                    <a:bodyPr/>
+                    <a:lstStyle/>
+                    <a:p>
+                      <a:pPr algn="l"/>
+                      <a:r>
+                        <a:rPr lang="ru-RU" sz="1000" dirty="0"/>
+                        <a:t>2–40 °C</a:t>
+                      </a:r>
+                    </a:p>
+                  </a:txBody>
+                  <a:tcPr/>
+                </a:tc>
+              </a:tr>
+              <a:tr h="502920">
+                <a:tc>
+                  <a:txBody>
+                    <a:bodyPr/>
+                    <a:lstStyle/>
+                    <a:p>
+                      <a:pPr algn="l"/>
+                      <a:r>
+                        <a:rPr lang="ru-RU" sz="1000" dirty="0"/>
+                        <a:t>3</a:t>
+                      </a:r>
+                    </a:p>
+                  </a:txBody>
+                  <a:tcPr/>
+                </a:tc>
+                <a:tc>
+                  <a:txBody>
+                    <a:bodyPr/>
+                    <a:lstStyle/>
+                    <a:p>
+                      <a:pPr algn="l"/>
+                      <a:r>
+                        <a:rPr lang="ru-RU" sz="1000" dirty="0"/>
+                        <a:t>Humidity</a:t>
+                      </a:r>
+                    </a:p>
+                  </a:txBody>
+                  <a:tcPr/>
+                </a:tc>
+                <a:tc>
+                  <a:txBody>
+                    <a:bodyPr/>
+                    <a:lstStyle/>
+                    <a:p>
+                      <a:pPr algn="l"/>
+                      <a:r>
+                        <a:rPr lang="ru-RU" sz="1000" dirty="0"/>
+                        <a:t>Влажность воздуха</a:t>
+                      </a:r>
+                    </a:p>
+                  </a:txBody>
+                  <a:tcPr/>
+                </a:tc>
+                <a:tc>
+                  <a:txBody>
+                    <a:bodyPr/>
+                    <a:lstStyle/>
+                    <a:p>
+                      <a:pPr algn="l"/>
+                      <a:r>
+                        <a:rPr lang="ru-RU" sz="1000" dirty="0"/>
+                        <a:t>числовой</a:t>
+                      </a:r>
+                    </a:p>
+                  </a:txBody>
+                  <a:tcPr/>
+                </a:tc>
+                <a:tc>
+                  <a:txBody>
+                    <a:bodyPr/>
+                    <a:lstStyle/>
+                    <a:p>
+                      <a:pPr algn="l"/>
+                      <a:r>
+                        <a:rPr lang="ru-RU" sz="1000" dirty="0"/>
+                        <a:t>11–100 %</a:t>
+                      </a:r>
+                    </a:p>
+                  </a:txBody>
+                  <a:tcPr/>
+                </a:tc>
+              </a:tr>
+              <a:tr h="502920">
+                <a:tc>
+                  <a:txBody>
+                    <a:bodyPr/>
+                    <a:lstStyle/>
+                    <a:p>
+                      <a:pPr algn="l"/>
+                      <a:r>
+                        <a:rPr lang="ru-RU" sz="1000" dirty="0"/>
+                        <a:t>4</a:t>
+                      </a:r>
+                    </a:p>
+                  </a:txBody>
+                  <a:tcPr/>
+                </a:tc>
+                <a:tc>
+                  <a:txBody>
+                    <a:bodyPr/>
+                    <a:lstStyle/>
+                    <a:p>
+                      <a:pPr algn="l"/>
+                      <a:r>
+                        <a:rPr lang="ru-RU" sz="1000" dirty="0"/>
+                        <a:t>Wind Speed</a:t>
+                      </a:r>
+                    </a:p>
+                  </a:txBody>
+                  <a:tcPr/>
+                </a:tc>
+                <a:tc>
+                  <a:txBody>
+                    <a:bodyPr/>
+                    <a:lstStyle/>
+                    <a:p>
+                      <a:pPr algn="l"/>
+                      <a:r>
+                        <a:rPr lang="ru-RU" sz="1000" dirty="0"/>
+                        <a:t>Скорость ветра</a:t>
+                      </a:r>
+                    </a:p>
+                  </a:txBody>
+                  <a:tcPr/>
+                </a:tc>
+                <a:tc>
+                  <a:txBody>
+                    <a:bodyPr/>
+                    <a:lstStyle/>
+                    <a:p>
+                      <a:pPr algn="l"/>
+                      <a:r>
+                        <a:rPr lang="ru-RU" sz="1000" dirty="0"/>
+                        <a:t>числовой</a:t>
+                      </a:r>
+                    </a:p>
+                  </a:txBody>
+                  <a:tcPr/>
+                </a:tc>
+                <a:tc>
+                  <a:txBody>
+                    <a:bodyPr/>
+                    <a:lstStyle/>
+                    <a:p>
+                      <a:pPr algn="l"/>
+                      <a:r>
+                        <a:rPr lang="ru-RU" sz="1000" dirty="0"/>
+                        <a:t>0–10 м/с</a:t>
+                      </a:r>
+                    </a:p>
+                  </a:txBody>
+                  <a:tcPr/>
+                </a:tc>
+              </a:tr>
+              <a:tr h="502920">
+                <a:tc>
+                  <a:txBody>
+                    <a:bodyPr/>
+                    <a:lstStyle/>
+                    <a:p>
+                      <a:pPr algn="l"/>
+                      <a:r>
+                        <a:rPr lang="ru-RU" sz="1000" dirty="0"/>
+                        <a:t>5</a:t>
+                      </a:r>
+                    </a:p>
+                  </a:txBody>
+                  <a:tcPr/>
+                </a:tc>
+                <a:tc>
+                  <a:txBody>
+                    <a:bodyPr/>
+                    <a:lstStyle/>
+                    <a:p>
+                      <a:pPr algn="l"/>
+                      <a:r>
+                        <a:rPr lang="ru-RU" sz="1000" dirty="0"/>
+                        <a:t>Gen. Diffuse Flows</a:t>
+                      </a:r>
+                    </a:p>
+                  </a:txBody>
+                  <a:tcPr/>
+                </a:tc>
+                <a:tc>
+                  <a:txBody>
+                    <a:bodyPr/>
+                    <a:lstStyle/>
+                    <a:p>
+                      <a:pPr algn="l"/>
+                      <a:r>
+                        <a:rPr lang="ru-RU" sz="1000" dirty="0"/>
+                        <a:t>Суммарная диффузная радиация</a:t>
+                      </a:r>
+                    </a:p>
+                  </a:txBody>
+                  <a:tcPr/>
+                </a:tc>
+                <a:tc>
+                  <a:txBody>
+                    <a:bodyPr/>
+                    <a:lstStyle/>
+                    <a:p>
+                      <a:pPr algn="l"/>
+                      <a:r>
+                        <a:rPr lang="ru-RU" sz="1000" dirty="0"/>
+                        <a:t>числовой</a:t>
+                      </a:r>
+                    </a:p>
+                  </a:txBody>
+                  <a:tcPr/>
+                </a:tc>
+                <a:tc>
+                  <a:txBody>
+                    <a:bodyPr/>
+                    <a:lstStyle/>
+                    <a:p>
+                      <a:pPr algn="l"/>
+                      <a:r>
+                        <a:rPr lang="ru-RU" sz="1000" dirty="0"/>
+                        <a:t>0–500 Вт/м²</a:t>
+                      </a:r>
+                    </a:p>
+                  </a:txBody>
+                  <a:tcPr/>
+                </a:tc>
+              </a:tr>
+              <a:tr h="502920">
+                <a:tc>
+                  <a:txBody>
+                    <a:bodyPr/>
+                    <a:lstStyle/>
+                    <a:p>
+                      <a:pPr algn="l"/>
+                      <a:r>
+                        <a:rPr lang="ru-RU" sz="1000" dirty="0"/>
+                        <a:t>6</a:t>
+                      </a:r>
+                    </a:p>
+                  </a:txBody>
+                  <a:tcPr/>
+                </a:tc>
+                <a:tc>
+                  <a:txBody>
+                    <a:bodyPr/>
+                    <a:lstStyle/>
+                    <a:p>
+                      <a:pPr algn="l"/>
+                      <a:r>
+                        <a:rPr lang="ru-RU" sz="1000" dirty="0"/>
+                        <a:t>Diffuse Flows</a:t>
+                      </a:r>
+                    </a:p>
+                  </a:txBody>
+                  <a:tcPr/>
+                </a:tc>
+                <a:tc>
+                  <a:txBody>
+                    <a:bodyPr/>
+                    <a:lstStyle/>
+                    <a:p>
+                      <a:pPr algn="l"/>
+                      <a:r>
+                        <a:rPr lang="ru-RU" sz="1000" dirty="0"/>
+                        <a:t>Диффузная радиация</a:t>
+                      </a:r>
+                    </a:p>
+                  </a:txBody>
+                  <a:tcPr/>
+                </a:tc>
+                <a:tc>
+                  <a:txBody>
+                    <a:bodyPr/>
+                    <a:lstStyle/>
+                    <a:p>
+                      <a:pPr algn="l"/>
+                      <a:r>
+                        <a:rPr lang="ru-RU" sz="1000" dirty="0"/>
+                        <a:t>числовой</a:t>
+                      </a:r>
+                    </a:p>
+                  </a:txBody>
+                  <a:tcPr/>
+                </a:tc>
+                <a:tc>
+                  <a:txBody>
+                    <a:bodyPr/>
+                    <a:lstStyle/>
+                    <a:p>
+                      <a:pPr algn="l"/>
+                      <a:r>
+                        <a:rPr lang="ru-RU" sz="1000" dirty="0"/>
+                        <a:t>0–500 Вт/м²</a:t>
+                      </a:r>
+                    </a:p>
+                  </a:txBody>
+                  <a:tcPr/>
+                </a:tc>
+              </a:tr>
+              <a:tr h="502920">
+                <a:tc>
+                  <a:txBody>
+                    <a:bodyPr/>
+                    <a:lstStyle/>
+                    <a:p>
+                      <a:pPr algn="l"/>
+                      <a:r>
+                        <a:rPr lang="ru-RU" sz="1000" dirty="0"/>
+                        <a:t>7</a:t>
+                      </a:r>
+                    </a:p>
+                  </a:txBody>
+                  <a:tcPr/>
+                </a:tc>
+                <a:tc>
+                  <a:txBody>
+                    <a:bodyPr/>
+                    <a:lstStyle/>
+                    <a:p>
+                      <a:pPr algn="l"/>
+                      <a:r>
+                        <a:rPr lang="ru-RU" sz="1000" dirty="0"/>
+                        <a:t>Zone 1 Power Consump.</a:t>
+                      </a:r>
+                    </a:p>
+                  </a:txBody>
+                  <a:tcPr/>
+                </a:tc>
+                <a:tc>
+                  <a:txBody>
+                    <a:bodyPr/>
+                    <a:lstStyle/>
+                    <a:p>
+                      <a:pPr algn="l"/>
+                      <a:r>
+                        <a:rPr lang="ru-RU" sz="1000" dirty="0"/>
+                        <a:t>Потребление зоны 1 (ЦЕЛЬ)</a:t>
+                      </a:r>
+                    </a:p>
+                  </a:txBody>
+                  <a:tcPr/>
+                </a:tc>
+                <a:tc>
+                  <a:txBody>
+                    <a:bodyPr/>
+                    <a:lstStyle/>
+                    <a:p>
+                      <a:pPr algn="l"/>
+                      <a:r>
+                        <a:rPr lang="ru-RU" sz="1000" dirty="0"/>
+                        <a:t>числовой</a:t>
+                      </a:r>
+                    </a:p>
+                  </a:txBody>
+                  <a:tcPr/>
+                </a:tc>
+                <a:tc>
+                  <a:txBody>
+                    <a:bodyPr/>
+                    <a:lstStyle/>
+                    <a:p>
+                      <a:pPr algn="l"/>
+                      <a:r>
+                        <a:rPr lang="ru-RU" sz="1000" dirty="0"/>
+                        <a:t>11 200–82 300 кВт</a:t>
+                      </a:r>
+                    </a:p>
+                  </a:txBody>
+                  <a:tcPr/>
+                </a:tc>
+              </a:tr>
+              <a:tr h="502920">
+                <a:tc>
+                  <a:txBody>
+                    <a:bodyPr/>
+                    <a:lstStyle/>
+                    <a:p>
+                      <a:pPr algn="l"/>
+                      <a:r>
+                        <a:rPr lang="ru-RU" sz="1000" dirty="0"/>
+                        <a:t>8</a:t>
+                      </a:r>
+                    </a:p>
+                  </a:txBody>
+                  <a:tcPr/>
+                </a:tc>
+                <a:tc>
+                  <a:txBody>
+                    <a:bodyPr/>
+                    <a:lstStyle/>
+                    <a:p>
+                      <a:pPr algn="l"/>
+                      <a:r>
+                        <a:rPr lang="ru-RU" sz="1000" dirty="0"/>
+                        <a:t>Zone 2 Power Consump.</a:t>
+                      </a:r>
+                    </a:p>
+                  </a:txBody>
+                  <a:tcPr/>
+                </a:tc>
+                <a:tc>
+                  <a:txBody>
+                    <a:bodyPr/>
+                    <a:lstStyle/>
+                    <a:p>
+                      <a:pPr algn="l"/>
+                      <a:r>
+                        <a:rPr lang="ru-RU" sz="1000" dirty="0"/>
+                        <a:t>Потребление зоны 2 (ЦЕЛЬ)</a:t>
+                      </a:r>
+                    </a:p>
+                  </a:txBody>
+                  <a:tcPr/>
+                </a:tc>
+                <a:tc>
+                  <a:txBody>
+                    <a:bodyPr/>
+                    <a:lstStyle/>
+                    <a:p>
+                      <a:pPr algn="l"/>
+                      <a:r>
+                        <a:rPr lang="ru-RU" sz="1000" dirty="0"/>
+                        <a:t>числовой</a:t>
+                      </a:r>
+                    </a:p>
+                  </a:txBody>
+                  <a:tcPr/>
+                </a:tc>
+                <a:tc>
+                  <a:txBody>
+                    <a:bodyPr/>
+                    <a:lstStyle/>
+                    <a:p>
+                      <a:pPr algn="l"/>
+                      <a:r>
+                        <a:rPr lang="ru-RU" sz="1000" dirty="0"/>
+                        <a:t>7 000–52 000 кВт</a:t>
+                      </a:r>
+                    </a:p>
+                  </a:txBody>
+                  <a:tcPr/>
+                </a:tc>
+              </a:tr>
+              <a:tr h="502920">
+                <a:tc>
+                  <a:txBody>
+                    <a:bodyPr/>
+                    <a:lstStyle/>
+                    <a:p>
+                      <a:pPr algn="l"/>
+                      <a:r>
+                        <a:rPr lang="ru-RU" sz="1000" dirty="0"/>
+                        <a:t>9</a:t>
+                      </a:r>
+                    </a:p>
+                  </a:txBody>
+                  <a:tcPr/>
+                </a:tc>
+                <a:tc>
+                  <a:txBody>
+                    <a:bodyPr/>
+                    <a:lstStyle/>
+                    <a:p>
+                      <a:pPr algn="l"/>
+                      <a:r>
+                        <a:rPr lang="ru-RU" sz="1000" dirty="0"/>
+                        <a:t>Zone 3 Power Consump.</a:t>
+                      </a:r>
+                    </a:p>
+                  </a:txBody>
+                  <a:tcPr/>
+                </a:tc>
+                <a:tc>
+                  <a:txBody>
+                    <a:bodyPr/>
+                    <a:lstStyle/>
+                    <a:p>
+                      <a:pPr algn="l"/>
+                      <a:r>
+                        <a:rPr lang="ru-RU" sz="1000" dirty="0"/>
+                        <a:t>Потребление зоны 3 (ЦЕЛЬ)</a:t>
+                      </a:r>
+                    </a:p>
+                  </a:txBody>
+                  <a:tcPr/>
+                </a:tc>
+                <a:tc>
+                  <a:txBody>
+                    <a:bodyPr/>
+                    <a:lstStyle/>
+                    <a:p>
+                      <a:pPr algn="l"/>
+                      <a:r>
+                        <a:rPr lang="ru-RU" sz="1000" dirty="0"/>
+                        <a:t>числовой</a:t>
+                      </a:r>
+                    </a:p>
+                  </a:txBody>
+                  <a:tcPr/>
+                </a:tc>
+                <a:tc>
+                  <a:txBody>
+                    <a:bodyPr/>
+                    <a:lstStyle/>
+                    <a:p>
+                      <a:pPr algn="l"/>
+                      <a:r>
+                        <a:rPr lang="ru-RU" sz="1000" dirty="0"/>
+                        <a:t>6 300–44 000 кВт</a:t>
+                      </a:r>
+                    </a:p>
+                  </a:txBody>
+                  <a:tcPr/>
+                </a:tc>
+              </a:tr>
+            </a:tbl>
+          </a:graphicData>
+        </a:graphic>
+      </p:graphicFrame>
+    </p:spTree>
+  </p:cSld>
+  <p:clrMapOvr>
+    <a:masterClrMapping/>
+  </p:clrMapOvr>
+</p:sld>
+</file>
+
 <file path=ppt/slides/slide3.xml><?xml version="1.0" encoding="utf-8"?>
 <p:sld xmlns:a="http://schemas.openxmlformats.org/drawingml/2006/main" xmlns:r="http://schemas.openxmlformats.org/officeDocument/2006/relationships" xmlns:p="http://schemas.openxmlformats.org/presentationml/2006/main">
   <p:cSld name="Slide 3">
@@ -14909,6 +17281,763 @@
           </a:p>
         </p:txBody>
       </p:sp>
+    </p:spTree>
+  </p:cSld>
+  <p:clrMapOvr>
+    <a:masterClrMapping/>
+  </p:clrMapOvr>
+</p:sld>
+</file>
+
+<file path=ppt/slides/slide30.xml><?xml version="1.0" encoding="utf-8"?>
+<p:sld xmlns:a="http://schemas.openxmlformats.org/drawingml/2006/main" xmlns:p="http://schemas.openxmlformats.org/presentationml/2006/main" xmlns:r="http://schemas.openxmlformats.org/officeDocument/2006/relationships">
+  <p:cSld>
+    <p:bg>
+      <p:bgPr>
+        <a:solidFill>
+          <a:srgbClr val="FFFFFF"/>
+        </a:solidFill>
+      </p:bgPr>
+    </p:bg>
+    <p:spTree>
+      <p:nvGrpSpPr>
+        <p:cNvPr id="1" name=""/>
+        <p:cNvGrpSpPr/>
+        <p:nvPr/>
+      </p:nvGrpSpPr>
+      <p:grpSpPr>
+        <a:xfrm>
+          <a:off x="0" y="0"/>
+          <a:ext cx="0" cy="0"/>
+          <a:chOff x="0" y="0"/>
+          <a:chExt cx="0" cy="0"/>
+        </a:xfrm>
+      </p:grpSpPr>
+      <p:sp>
+        <p:nvSpPr>
+          <p:cNvPr id="2" name="title"/>
+          <p:cNvSpPr txBox="1"/>
+          <p:nvPr/>
+        </p:nvSpPr>
+        <p:spPr>
+          <a:xfrm>
+            <a:off x="457200" y="457200"/>
+            <a:ext cx="8229600" cy="685800"/>
+          </a:xfrm>
+          <a:prstGeom prst="rect">
+            <a:avLst/>
+          </a:prstGeom>
+          <a:solidFill>
+            <a:srgbClr val="1F3864"/>
+          </a:solidFill>
+        </p:spPr>
+        <p:txBody>
+          <a:bodyPr wrap="square" rtlCol="0" anchor="ctr" lIns="91440" tIns="45720" rIns="91440" bIns="45720"/>
+          <a:lstStyle/>
+          <a:p>
+            <a:pPr algn="l"/>
+            <a:r>
+              <a:rPr lang="ru-RU" sz="1800" dirty="0">
+                <a:b/>
+                <a:solidFill>
+                  <a:srgbClr val="FFFFFF"/>
+                </a:solidFill>
+              </a:rPr>
+              <a:t>ГЛАВА 3 — ИЗОБРАЖЕНИЯ   Параметры датасета Chest X-Ray Pneumonia</a:t>
+            </a:r>
+          </a:p>
+        </p:txBody>
+      </p:sp>
+      <p:graphicFrame>
+        <p:nvGraphicFramePr>
+          <p:cNvPr id="4" name="Table 1"/>
+          <p:cNvGraphicFramePr/>
+          <p:nvPr/>
+        </p:nvGraphicFramePr>
+        <a:xfrm>
+          <a:off x="457200" y="1371600"/>
+          <a:ext cx="8229600" cy="5029200"/>
+        </a:xfrm>
+        <a:graphic>
+          <a:graphicData uri="http://schemas.openxmlformats.org/drawingml/2006/table">
+            <a:tbl xmlns:a="http://schemas.openxmlformats.org/drawingml/2006/main">
+              <a:tblPr firstRow="1" bandRow="1">
+                <a:tableStyleId>{5C22544A-7EE6-4342-B048-85BDC9FD1C3A}</a:tableStyleId>
+              </a:tblPr>
+              <a:tblGrid>
+                <a:gridCol w="2743200"/>
+                <a:gridCol w="5486400"/>
+              </a:tblGrid>
+              <a:tr h="558800">
+                <a:tc>
+                  <a:txBody>
+                    <a:bodyPr/>
+                    <a:lstStyle/>
+                    <a:p>
+                      <a:pPr algn="l"/>
+                      <a:r>
+                        <a:rPr lang="ru-RU" sz="1100" dirty="0">
+                          <a:b/>
+                        </a:rPr>
+                        <a:t>Параметр</a:t>
+                      </a:r>
+                    </a:p>
+                  </a:txBody>
+                  <a:tcPr/>
+                </a:tc>
+                <a:tc>
+                  <a:txBody>
+                    <a:bodyPr/>
+                    <a:lstStyle/>
+                    <a:p>
+                      <a:pPr algn="l"/>
+                      <a:r>
+                        <a:rPr lang="ru-RU" sz="1100" dirty="0">
+                          <a:b/>
+                        </a:rPr>
+                        <a:t>Описание</a:t>
+                      </a:r>
+                    </a:p>
+                  </a:txBody>
+                  <a:tcPr/>
+                </a:tc>
+              </a:tr>
+              <a:tr h="558800">
+                <a:tc>
+                  <a:txBody>
+                    <a:bodyPr/>
+                    <a:lstStyle/>
+                    <a:p>
+                      <a:pPr algn="l"/>
+                      <a:r>
+                        <a:rPr lang="ru-RU" sz="1000" dirty="0"/>
+                        <a:t>Метка класса</a:t>
+                      </a:r>
+                    </a:p>
+                  </a:txBody>
+                  <a:tcPr/>
+                </a:tc>
+                <a:tc>
+                  <a:txBody>
+                    <a:bodyPr/>
+                    <a:lstStyle/>
+                    <a:p>
+                      <a:pPr algn="l"/>
+                      <a:r>
+                        <a:rPr lang="ru-RU" sz="1000" dirty="0"/>
+                        <a:t>NORMAL / PNEUMONIA (бинарная)</a:t>
+                      </a:r>
+                    </a:p>
+                  </a:txBody>
+                  <a:tcPr/>
+                </a:tc>
+              </a:tr>
+              <a:tr h="558800">
+                <a:tc>
+                  <a:txBody>
+                    <a:bodyPr/>
+                    <a:lstStyle/>
+                    <a:p>
+                      <a:pPr algn="l"/>
+                      <a:r>
+                        <a:rPr lang="ru-RU" sz="1000" dirty="0"/>
+                        <a:t>Формат файлов</a:t>
+                      </a:r>
+                    </a:p>
+                  </a:txBody>
+                  <a:tcPr/>
+                </a:tc>
+                <a:tc>
+                  <a:txBody>
+                    <a:bodyPr/>
+                    <a:lstStyle/>
+                    <a:p>
+                      <a:pPr algn="l"/>
+                      <a:r>
+                        <a:rPr lang="ru-RU" sz="1000" dirty="0"/>
+                        <a:t>JPEG, полутоновые рентгенограммы</a:t>
+                      </a:r>
+                    </a:p>
+                  </a:txBody>
+                  <a:tcPr/>
+                </a:tc>
+              </a:tr>
+              <a:tr h="558800">
+                <a:tc>
+                  <a:txBody>
+                    <a:bodyPr/>
+                    <a:lstStyle/>
+                    <a:p>
+                      <a:pPr algn="l"/>
+                      <a:r>
+                        <a:rPr lang="ru-RU" sz="1000" dirty="0"/>
+                        <a:t>Разрешение</a:t>
+                      </a:r>
+                    </a:p>
+                  </a:txBody>
+                  <a:tcPr/>
+                </a:tc>
+                <a:tc>
+                  <a:txBody>
+                    <a:bodyPr/>
+                    <a:lstStyle/>
+                    <a:p>
+                      <a:pPr algn="l"/>
+                      <a:r>
+                        <a:rPr lang="ru-RU" sz="1000" dirty="0"/>
+                        <a:t>360–2916 × 313–2583 пикселей (неоднородное)</a:t>
+                      </a:r>
+                    </a:p>
+                  </a:txBody>
+                  <a:tcPr/>
+                </a:tc>
+              </a:tr>
+              <a:tr h="558800">
+                <a:tc>
+                  <a:txBody>
+                    <a:bodyPr/>
+                    <a:lstStyle/>
+                    <a:p>
+                      <a:pPr algn="l"/>
+                      <a:r>
+                        <a:rPr lang="ru-RU" sz="1000" dirty="0"/>
+                        <a:t>Обучающая выборка</a:t>
+                      </a:r>
+                    </a:p>
+                  </a:txBody>
+                  <a:tcPr/>
+                </a:tc>
+                <a:tc>
+                  <a:txBody>
+                    <a:bodyPr/>
+                    <a:lstStyle/>
+                    <a:p>
+                      <a:pPr algn="l"/>
+                      <a:r>
+                        <a:rPr lang="ru-RU" sz="1000" dirty="0"/>
+                        <a:t>5 216 снимков (PNEUMONIA: 3 875 / NORMAL: 1 341)</a:t>
+                      </a:r>
+                    </a:p>
+                  </a:txBody>
+                  <a:tcPr/>
+                </a:tc>
+              </a:tr>
+              <a:tr h="558800">
+                <a:tc>
+                  <a:txBody>
+                    <a:bodyPr/>
+                    <a:lstStyle/>
+                    <a:p>
+                      <a:pPr algn="l"/>
+                      <a:r>
+                        <a:rPr lang="ru-RU" sz="1000" dirty="0"/>
+                        <a:t>Тестовая выборка</a:t>
+                      </a:r>
+                    </a:p>
+                  </a:txBody>
+                  <a:tcPr/>
+                </a:tc>
+                <a:tc>
+                  <a:txBody>
+                    <a:bodyPr/>
+                    <a:lstStyle/>
+                    <a:p>
+                      <a:pPr algn="l"/>
+                      <a:r>
+                        <a:rPr lang="ru-RU" sz="1000" dirty="0"/>
+                        <a:t>624 снимка (PNEUMONIA: 390 / NORMAL: 234)</a:t>
+                      </a:r>
+                    </a:p>
+                  </a:txBody>
+                  <a:tcPr/>
+                </a:tc>
+              </a:tr>
+              <a:tr h="558800">
+                <a:tc>
+                  <a:txBody>
+                    <a:bodyPr/>
+                    <a:lstStyle/>
+                    <a:p>
+                      <a:pPr algn="l"/>
+                      <a:r>
+                        <a:rPr lang="ru-RU" sz="1000" dirty="0"/>
+                        <a:t>Валидационная</a:t>
+                      </a:r>
+                    </a:p>
+                  </a:txBody>
+                  <a:tcPr/>
+                </a:tc>
+                <a:tc>
+                  <a:txBody>
+                    <a:bodyPr/>
+                    <a:lstStyle/>
+                    <a:p>
+                      <a:pPr algn="l"/>
+                      <a:r>
+                        <a:rPr lang="ru-RU" sz="1000" dirty="0"/>
+                        <a:t>16 снимков</a:t>
+                      </a:r>
+                    </a:p>
+                  </a:txBody>
+                  <a:tcPr/>
+                </a:tc>
+              </a:tr>
+              <a:tr h="558800">
+                <a:tc>
+                  <a:txBody>
+                    <a:bodyPr/>
+                    <a:lstStyle/>
+                    <a:p>
+                      <a:pPr algn="l"/>
+                      <a:r>
+                        <a:rPr lang="ru-RU" sz="1000" dirty="0"/>
+                        <a:t>Источник разметки</a:t>
+                      </a:r>
+                    </a:p>
+                  </a:txBody>
+                  <a:tcPr/>
+                </a:tc>
+                <a:tc>
+                  <a:txBody>
+                    <a:bodyPr/>
+                    <a:lstStyle/>
+                    <a:p>
+                      <a:pPr algn="l"/>
+                      <a:r>
+                        <a:rPr lang="ru-RU" sz="1000" dirty="0"/>
+                        <a:t>Специалисты-радиологи Детской больницы Гуанчжоу</a:t>
+                      </a:r>
+                    </a:p>
+                  </a:txBody>
+                  <a:tcPr/>
+                </a:tc>
+              </a:tr>
+              <a:tr h="558800">
+                <a:tc>
+                  <a:txBody>
+                    <a:bodyPr/>
+                    <a:lstStyle/>
+                    <a:p>
+                      <a:pPr algn="l"/>
+                      <a:r>
+                        <a:rPr lang="ru-RU" sz="1000" dirty="0"/>
+                        <a:t>Ограничение</a:t>
+                      </a:r>
+                    </a:p>
+                  </a:txBody>
+                  <a:tcPr/>
+                </a:tc>
+                <a:tc>
+                  <a:txBody>
+                    <a:bodyPr/>
+                    <a:lstStyle/>
+                    <a:p>
+                      <a:pPr algn="l"/>
+                      <a:r>
+                        <a:rPr lang="ru-RU" sz="1000" dirty="0"/>
+                        <a:t>Тип пневмонии (бактер./вирус.) в имени файла</a:t>
+                      </a:r>
+                    </a:p>
+                  </a:txBody>
+                  <a:tcPr/>
+                </a:tc>
+              </a:tr>
+            </a:tbl>
+          </a:graphicData>
+        </a:graphic>
+      </p:graphicFrame>
+    </p:spTree>
+  </p:cSld>
+  <p:clrMapOvr>
+    <a:masterClrMapping/>
+  </p:clrMapOvr>
+</p:sld>
+</file>
+
+<file path=ppt/slides/slide31.xml><?xml version="1.0" encoding="utf-8"?>
+<p:sld xmlns:a="http://schemas.openxmlformats.org/drawingml/2006/main" xmlns:p="http://schemas.openxmlformats.org/presentationml/2006/main" xmlns:r="http://schemas.openxmlformats.org/officeDocument/2006/relationships">
+  <p:cSld>
+    <p:bg>
+      <p:bgPr>
+        <a:solidFill>
+          <a:srgbClr val="FFFFFF"/>
+        </a:solidFill>
+      </p:bgPr>
+    </p:bg>
+    <p:spTree>
+      <p:nvGrpSpPr>
+        <p:cNvPr id="1" name=""/>
+        <p:cNvGrpSpPr/>
+        <p:nvPr/>
+      </p:nvGrpSpPr>
+      <p:grpSpPr>
+        <a:xfrm>
+          <a:off x="0" y="0"/>
+          <a:ext cx="0" cy="0"/>
+          <a:chOff x="0" y="0"/>
+          <a:chExt cx="0" cy="0"/>
+        </a:xfrm>
+      </p:grpSpPr>
+      <p:sp>
+        <p:nvSpPr>
+          <p:cNvPr id="2" name="title"/>
+          <p:cNvSpPr txBox="1"/>
+          <p:nvPr/>
+        </p:nvSpPr>
+        <p:spPr>
+          <a:xfrm>
+            <a:off x="457200" y="457200"/>
+            <a:ext cx="8229600" cy="685800"/>
+          </a:xfrm>
+          <a:prstGeom prst="rect">
+            <a:avLst/>
+          </a:prstGeom>
+          <a:solidFill>
+            <a:srgbClr val="1F3864"/>
+          </a:solidFill>
+        </p:spPr>
+        <p:txBody>
+          <a:bodyPr wrap="square" rtlCol="0" anchor="ctr" lIns="91440" tIns="45720" rIns="91440" bIns="45720"/>
+          <a:lstStyle/>
+          <a:p>
+            <a:pPr algn="l"/>
+            <a:r>
+              <a:rPr lang="ru-RU" sz="1800" dirty="0">
+                <a:b/>
+                <a:solidFill>
+                  <a:srgbClr val="FFFFFF"/>
+                </a:solidFill>
+              </a:rPr>
+              <a:t>ГЛАВА 4 — ТЕКСТ   Атрибуты датасета BBC News Classification</a:t>
+            </a:r>
+          </a:p>
+        </p:txBody>
+      </p:sp>
+      <p:graphicFrame>
+        <p:nvGraphicFramePr>
+          <p:cNvPr id="4" name="Table 1"/>
+          <p:cNvGraphicFramePr/>
+          <p:nvPr/>
+        </p:nvGraphicFramePr>
+        <a:xfrm>
+          <a:off x="457200" y="1371600"/>
+          <a:ext cx="8229600" cy="5029200"/>
+        </a:xfrm>
+        <a:graphic>
+          <a:graphicData uri="http://schemas.openxmlformats.org/drawingml/2006/table">
+            <a:tbl xmlns:a="http://schemas.openxmlformats.org/drawingml/2006/main">
+              <a:tblPr firstRow="1" bandRow="1">
+                <a:tableStyleId>{5C22544A-7EE6-4342-B048-85BDC9FD1C3A}</a:tableStyleId>
+              </a:tblPr>
+              <a:tblGrid>
+                <a:gridCol w="561109"/>
+                <a:gridCol w="1122218"/>
+                <a:gridCol w="2618509"/>
+                <a:gridCol w="935181"/>
+                <a:gridCol w="2992581"/>
+              </a:tblGrid>
+              <a:tr h="1257300">
+                <a:tc>
+                  <a:txBody>
+                    <a:bodyPr/>
+                    <a:lstStyle/>
+                    <a:p>
+                      <a:pPr algn="l"/>
+                      <a:r>
+                        <a:rPr lang="ru-RU" sz="1100" dirty="0">
+                          <a:b/>
+                        </a:rPr>
+                        <a:t>№</a:t>
+                      </a:r>
+                    </a:p>
+                  </a:txBody>
+                  <a:tcPr/>
+                </a:tc>
+                <a:tc>
+                  <a:txBody>
+                    <a:bodyPr/>
+                    <a:lstStyle/>
+                    <a:p>
+                      <a:pPr algn="l"/>
+                      <a:r>
+                        <a:rPr lang="ru-RU" sz="1100" dirty="0">
+                          <a:b/>
+                        </a:rPr>
+                        <a:t>Название</a:t>
+                      </a:r>
+                    </a:p>
+                  </a:txBody>
+                  <a:tcPr/>
+                </a:tc>
+                <a:tc>
+                  <a:txBody>
+                    <a:bodyPr/>
+                    <a:lstStyle/>
+                    <a:p>
+                      <a:pPr algn="l"/>
+                      <a:r>
+                        <a:rPr lang="ru-RU" sz="1100" dirty="0">
+                          <a:b/>
+                        </a:rPr>
+                        <a:t>Семантика</a:t>
+                      </a:r>
+                    </a:p>
+                  </a:txBody>
+                  <a:tcPr/>
+                </a:tc>
+                <a:tc>
+                  <a:txBody>
+                    <a:bodyPr/>
+                    <a:lstStyle/>
+                    <a:p>
+                      <a:pPr algn="l"/>
+                      <a:r>
+                        <a:rPr lang="ru-RU" sz="1100" dirty="0">
+                          <a:b/>
+                        </a:rPr>
+                        <a:t>Тип</a:t>
+                      </a:r>
+                    </a:p>
+                  </a:txBody>
+                  <a:tcPr/>
+                </a:tc>
+                <a:tc>
+                  <a:txBody>
+                    <a:bodyPr/>
+                    <a:lstStyle/>
+                    <a:p>
+                      <a:pPr algn="l"/>
+                      <a:r>
+                        <a:rPr lang="ru-RU" sz="1100" dirty="0">
+                          <a:b/>
+                        </a:rPr>
+                        <a:t>Значения</a:t>
+                      </a:r>
+                    </a:p>
+                  </a:txBody>
+                  <a:tcPr/>
+                </a:tc>
+              </a:tr>
+              <a:tr h="1257300">
+                <a:tc>
+                  <a:txBody>
+                    <a:bodyPr/>
+                    <a:lstStyle/>
+                    <a:p>
+                      <a:pPr algn="l"/>
+                      <a:r>
+                        <a:rPr lang="ru-RU" sz="1000" dirty="0"/>
+                        <a:t>1</a:t>
+                      </a:r>
+                    </a:p>
+                  </a:txBody>
+                  <a:tcPr/>
+                </a:tc>
+                <a:tc>
+                  <a:txBody>
+                    <a:bodyPr/>
+                    <a:lstStyle/>
+                    <a:p>
+                      <a:pPr algn="l"/>
+                      <a:r>
+                        <a:rPr lang="ru-RU" sz="1000" dirty="0"/>
+                        <a:t>category</a:t>
+                      </a:r>
+                    </a:p>
+                  </a:txBody>
+                  <a:tcPr/>
+                </a:tc>
+                <a:tc>
+                  <a:txBody>
+                    <a:bodyPr/>
+                    <a:lstStyle/>
+                    <a:p>
+                      <a:pPr algn="l"/>
+                      <a:r>
+                        <a:rPr lang="ru-RU" sz="1000" dirty="0"/>
+                        <a:t>Тематическая категория (ЦЕЛЕВАЯ)</a:t>
+                      </a:r>
+                    </a:p>
+                  </a:txBody>
+                  <a:tcPr/>
+                </a:tc>
+                <a:tc>
+                  <a:txBody>
+                    <a:bodyPr/>
+                    <a:lstStyle/>
+                    <a:p>
+                      <a:pPr algn="l"/>
+                      <a:r>
+                        <a:rPr lang="ru-RU" sz="1000" dirty="0"/>
+                        <a:t>категор.</a:t>
+                      </a:r>
+                    </a:p>
+                  </a:txBody>
+                  <a:tcPr/>
+                </a:tc>
+                <a:tc>
+                  <a:txBody>
+                    <a:bodyPr/>
+                    <a:lstStyle/>
+                    <a:p>
+                      <a:pPr algn="l"/>
+                      <a:r>
+                        <a:rPr lang="ru-RU" sz="1000" dirty="0"/>
+                        <a:t>sport / business / politics / tech / entertainment</a:t>
+                      </a:r>
+                    </a:p>
+                  </a:txBody>
+                  <a:tcPr/>
+                </a:tc>
+              </a:tr>
+              <a:tr h="1257300">
+                <a:tc>
+                  <a:txBody>
+                    <a:bodyPr/>
+                    <a:lstStyle/>
+                    <a:p>
+                      <a:pPr algn="l"/>
+                      <a:r>
+                        <a:rPr lang="ru-RU" sz="1000" dirty="0"/>
+                        <a:t>2</a:t>
+                      </a:r>
+                    </a:p>
+                  </a:txBody>
+                  <a:tcPr/>
+                </a:tc>
+                <a:tc>
+                  <a:txBody>
+                    <a:bodyPr/>
+                    <a:lstStyle/>
+                    <a:p>
+                      <a:pPr algn="l"/>
+                      <a:r>
+                        <a:rPr lang="ru-RU" sz="1000" dirty="0"/>
+                        <a:t>text</a:t>
+                      </a:r>
+                    </a:p>
+                  </a:txBody>
+                  <a:tcPr/>
+                </a:tc>
+                <a:tc>
+                  <a:txBody>
+                    <a:bodyPr/>
+                    <a:lstStyle/>
+                    <a:p>
+                      <a:pPr algn="l"/>
+                      <a:r>
+                        <a:rPr lang="ru-RU" sz="1000" dirty="0"/>
+                        <a:t>Полный текст новостной статьи</a:t>
+                      </a:r>
+                    </a:p>
+                  </a:txBody>
+                  <a:tcPr/>
+                </a:tc>
+                <a:tc>
+                  <a:txBody>
+                    <a:bodyPr/>
+                    <a:lstStyle/>
+                    <a:p>
+                      <a:pPr algn="l"/>
+                      <a:r>
+                        <a:rPr lang="ru-RU" sz="1000" dirty="0"/>
+                        <a:t>текст</a:t>
+                      </a:r>
+                    </a:p>
+                  </a:txBody>
+                  <a:tcPr/>
+                </a:tc>
+                <a:tc>
+                  <a:txBody>
+                    <a:bodyPr/>
+                    <a:lstStyle/>
+                    <a:p>
+                      <a:pPr algn="l"/>
+                      <a:r>
+                        <a:rPr lang="ru-RU" sz="1000" dirty="0"/>
+                        <a:t>390 слов в среднем; 25 000 уник. слов</a:t>
+                      </a:r>
+                    </a:p>
+                  </a:txBody>
+                  <a:tcPr/>
+                </a:tc>
+              </a:tr>
+              <a:tr h="1257300">
+                <a:tc>
+                  <a:txBody>
+                    <a:bodyPr/>
+                    <a:lstStyle/>
+                    <a:p>
+                      <a:pPr algn="l"/>
+                      <a:r>
+                        <a:rPr lang="ru-RU" sz="1000" dirty="0"/>
+                        <a:t/>
+                      </a:r>
+                    </a:p>
+                  </a:txBody>
+                  <a:tcPr/>
+                </a:tc>
+                <a:tc>
+                  <a:txBody>
+                    <a:bodyPr/>
+                    <a:lstStyle/>
+                    <a:p>
+                      <a:pPr algn="l"/>
+                      <a:r>
+                        <a:rPr lang="ru-RU" sz="1000" dirty="0"/>
+                        <a:t>Всего</a:t>
+                      </a:r>
+                    </a:p>
+                  </a:txBody>
+                  <a:tcPr/>
+                </a:tc>
+                <a:tc>
+                  <a:txBody>
+                    <a:bodyPr/>
+                    <a:lstStyle/>
+                    <a:p>
+                      <a:pPr algn="l"/>
+                      <a:r>
+                        <a:rPr lang="ru-RU" sz="1000" dirty="0"/>
+                        <a:t>2 225 статей, 5 категорий</a:t>
+                      </a:r>
+                    </a:p>
+                  </a:txBody>
+                  <a:tcPr/>
+                </a:tc>
+                <a:tc>
+                  <a:txBody>
+                    <a:bodyPr/>
+                    <a:lstStyle/>
+                    <a:p>
+                      <a:pPr algn="l"/>
+                      <a:r>
+                        <a:rPr lang="ru-RU" sz="1000" dirty="0"/>
+                        <a:t/>
+                      </a:r>
+                    </a:p>
+                  </a:txBody>
+                  <a:tcPr/>
+                </a:tc>
+                <a:tc>
+                  <a:txBody>
+                    <a:bodyPr/>
+                    <a:lstStyle/>
+                    <a:p>
+                      <a:pPr algn="l"/>
+                      <a:r>
+                        <a:rPr lang="ru-RU" sz="1000" dirty="0"/>
+                        <a:t>sport:511, biz:510, pol:417, tech:401, ent:386</a:t>
+                      </a:r>
+                    </a:p>
+                  </a:txBody>
+                  <a:tcPr/>
+                </a:tc>
+              </a:tr>
+            </a:tbl>
+          </a:graphicData>
+        </a:graphic>
+      </p:graphicFrame>
     </p:spTree>
   </p:cSld>
   <p:clrMapOvr>
@@ -15144,7 +18273,7 @@
                 <a:ea typeface="Calibri" pitchFamily="34" charset="-122"/>
                 <a:cs typeface="Calibri" pitchFamily="34" charset="-120"/>
               </a:rPr>
-              <a:t>World Happiness Report 2021</a:t>
+              <a:t>World Happiness Report 2015–2021</a:t>
             </a:r>
             <a:endParaRPr lang="en-US" sz="1300" dirty="0"/>
           </a:p>
@@ -15183,7 +18312,7 @@
                 <a:ea typeface="Calibri" pitchFamily="34" charset="-122"/>
                 <a:cs typeface="Calibri" pitchFamily="34" charset="-120"/>
               </a:rPr>
-              <a:t>149 стран, 20 признаков</a:t>
+              <a:t>1 084 страно-лет, 21 признак</a:t>
             </a:r>
             <a:endParaRPr lang="en-US" sz="1100" dirty="0"/>
           </a:p>
@@ -15340,7 +18469,7 @@
                 <a:ea typeface="Calibri" pitchFamily="34" charset="-122"/>
                 <a:cs typeface="Calibri" pitchFamily="34" charset="-120"/>
               </a:rPr>
-              <a:t>Human Activity Recognition (HAR)</a:t>
+              <a:t>Power Consumption of Tetouan City</a:t>
             </a:r>
             <a:endParaRPr lang="en-US" sz="1300" dirty="0"/>
           </a:p>
@@ -15379,7 +18508,7 @@
                 <a:ea typeface="Calibri" pitchFamily="34" charset="-122"/>
                 <a:cs typeface="Calibri" pitchFamily="34" charset="-120"/>
               </a:rPr>
-              <a:t>10 299 записей, 561 признак, 6 классов</a:t>
+              <a:t>52 416 записей, 8 каналов, 10-мин шаг</a:t>
             </a:r>
             <a:endParaRPr lang="en-US" sz="1100" dirty="0"/>
           </a:p>
@@ -16230,7 +19359,7 @@
                 <a:ea typeface="Calibri" pitchFamily="34" charset="-122"/>
                 <a:cs typeface="Calibri" pitchFamily="34" charset="-120"/>
               </a:rPr>
-              <a:t>Датасет: World Happiness Report 2021</a:t>
+              <a:t>Датасет: World Happiness Report 2015–2021</a:t>
             </a:r>
             <a:endParaRPr lang="en-US" sz="2400" dirty="0"/>
           </a:p>
@@ -16390,7 +19519,7 @@
                             <a:srgbClr val="263238"/>
                           </a:solidFill>
                         </a:rPr>
-                        <a:t>149 стран × 20 признаков</a:t>
+                        <a:t>1 084 страно-лет × 21 признак</a:t>
                       </a:r>
                       <a:endParaRPr lang="en-US" sz="1200" dirty="0"/>
                     </a:p>

</xml_diff>